<commit_message>
actualizo analisis y presentacion
</commit_message>
<xml_diff>
--- a/Equip_28/Results/Analisis_PAP_and_ABL_RapidExpres.pptx
+++ b/Equip_28/Results/Analisis_PAP_and_ABL_RapidExpres.pptx
@@ -209,7 +209,7 @@
           <a:p>
             <a:fld id="{443A06E2-0DF3-432C-9669-7DF986ACE8BA}" type="datetimeFigureOut">
               <a:rPr lang="en-GB" smtClean="0"/>
-              <a:t>23/04/2026</a:t>
+              <a:t>24/04/2026</a:t>
             </a:fld>
             <a:endParaRPr lang="en-GB"/>
           </a:p>
@@ -1502,7 +1502,7 @@
           <a:p>
             <a:fld id="{037D434A-83FD-40C7-B814-5B722EE835FE}" type="datetimeFigureOut">
               <a:rPr lang="en-GB" smtClean="0"/>
-              <a:t>23/04/2026</a:t>
+              <a:t>24/04/2026</a:t>
             </a:fld>
             <a:endParaRPr lang="en-GB"/>
           </a:p>
@@ -1702,7 +1702,7 @@
           <a:p>
             <a:fld id="{037D434A-83FD-40C7-B814-5B722EE835FE}" type="datetimeFigureOut">
               <a:rPr lang="en-GB" smtClean="0"/>
-              <a:t>23/04/2026</a:t>
+              <a:t>24/04/2026</a:t>
             </a:fld>
             <a:endParaRPr lang="en-GB"/>
           </a:p>
@@ -1912,7 +1912,7 @@
           <a:p>
             <a:fld id="{037D434A-83FD-40C7-B814-5B722EE835FE}" type="datetimeFigureOut">
               <a:rPr lang="en-GB" smtClean="0"/>
-              <a:t>23/04/2026</a:t>
+              <a:t>24/04/2026</a:t>
             </a:fld>
             <a:endParaRPr lang="en-GB"/>
           </a:p>
@@ -5944,7 +5944,7 @@
           <a:p>
             <a:fld id="{037D434A-83FD-40C7-B814-5B722EE835FE}" type="datetimeFigureOut">
               <a:rPr lang="en-GB" smtClean="0"/>
-              <a:t>23/04/2026</a:t>
+              <a:t>24/04/2026</a:t>
             </a:fld>
             <a:endParaRPr lang="en-GB"/>
           </a:p>
@@ -6220,7 +6220,7 @@
           <a:p>
             <a:fld id="{037D434A-83FD-40C7-B814-5B722EE835FE}" type="datetimeFigureOut">
               <a:rPr lang="en-GB" smtClean="0"/>
-              <a:t>23/04/2026</a:t>
+              <a:t>24/04/2026</a:t>
             </a:fld>
             <a:endParaRPr lang="en-GB"/>
           </a:p>
@@ -6488,7 +6488,7 @@
           <a:p>
             <a:fld id="{037D434A-83FD-40C7-B814-5B722EE835FE}" type="datetimeFigureOut">
               <a:rPr lang="en-GB" smtClean="0"/>
-              <a:t>23/04/2026</a:t>
+              <a:t>24/04/2026</a:t>
             </a:fld>
             <a:endParaRPr lang="en-GB"/>
           </a:p>
@@ -6903,7 +6903,7 @@
           <a:p>
             <a:fld id="{037D434A-83FD-40C7-B814-5B722EE835FE}" type="datetimeFigureOut">
               <a:rPr lang="en-GB" smtClean="0"/>
-              <a:t>23/04/2026</a:t>
+              <a:t>24/04/2026</a:t>
             </a:fld>
             <a:endParaRPr lang="en-GB"/>
           </a:p>
@@ -7045,7 +7045,7 @@
           <a:p>
             <a:fld id="{037D434A-83FD-40C7-B814-5B722EE835FE}" type="datetimeFigureOut">
               <a:rPr lang="en-GB" smtClean="0"/>
-              <a:t>23/04/2026</a:t>
+              <a:t>24/04/2026</a:t>
             </a:fld>
             <a:endParaRPr lang="en-GB"/>
           </a:p>
@@ -7158,7 +7158,7 @@
           <a:p>
             <a:fld id="{037D434A-83FD-40C7-B814-5B722EE835FE}" type="datetimeFigureOut">
               <a:rPr lang="en-GB" smtClean="0"/>
-              <a:t>23/04/2026</a:t>
+              <a:t>24/04/2026</a:t>
             </a:fld>
             <a:endParaRPr lang="en-GB"/>
           </a:p>
@@ -7471,7 +7471,7 @@
           <a:p>
             <a:fld id="{037D434A-83FD-40C7-B814-5B722EE835FE}" type="datetimeFigureOut">
               <a:rPr lang="en-GB" smtClean="0"/>
-              <a:t>23/04/2026</a:t>
+              <a:t>24/04/2026</a:t>
             </a:fld>
             <a:endParaRPr lang="en-GB"/>
           </a:p>
@@ -7760,7 +7760,7 @@
           <a:p>
             <a:fld id="{037D434A-83FD-40C7-B814-5B722EE835FE}" type="datetimeFigureOut">
               <a:rPr lang="en-GB" smtClean="0"/>
-              <a:t>23/04/2026</a:t>
+              <a:t>24/04/2026</a:t>
             </a:fld>
             <a:endParaRPr lang="en-GB"/>
           </a:p>
@@ -8003,7 +8003,7 @@
           <a:p>
             <a:fld id="{037D434A-83FD-40C7-B814-5B722EE835FE}" type="datetimeFigureOut">
               <a:rPr lang="en-GB" smtClean="0"/>
-              <a:t>23/04/2026</a:t>
+              <a:t>24/04/2026</a:t>
             </a:fld>
             <a:endParaRPr lang="en-GB"/>
           </a:p>
@@ -8676,7 +8676,23 @@
                   <a:schemeClr val="bg1"/>
                 </a:solidFill>
               </a:rPr>
-              <a:t> para reducer </a:t>
+              <a:t> para </a:t>
+            </a:r>
+            <a:r>
+              <a:rPr lang="en-US" dirty="0" err="1">
+                <a:solidFill>
+                  <a:schemeClr val="bg1"/>
+                </a:solidFill>
+              </a:rPr>
+              <a:t>reducir</a:t>
+            </a:r>
+            <a:r>
+              <a:rPr lang="en-US" dirty="0">
+                <a:solidFill>
+                  <a:schemeClr val="bg1"/>
+                </a:solidFill>
+              </a:rPr>
+              <a:t> </a:t>
             </a:r>
             <a:r>
               <a:rPr lang="en-US" dirty="0" err="1">
@@ -8739,10 +8755,6 @@
           <a:bodyPr/>
           <a:lstStyle/>
           <a:p>
-            <a:r>
-              <a:rPr lang="en-US" dirty="0" err="1"/>
-              <a:t>xxxxxxxx</a:t>
-            </a:r>
             <a:endParaRPr lang="en-US" dirty="0"/>
           </a:p>
         </p:txBody>
@@ -9047,12 +9059,209 @@
             <p:ph idx="30"/>
           </p:nvPr>
         </p:nvSpPr>
-        <p:spPr/>
+        <p:spPr>
+          <a:xfrm>
+            <a:off x="914398" y="2128603"/>
+            <a:ext cx="9653667" cy="3374136"/>
+          </a:xfrm>
+        </p:spPr>
         <p:txBody>
           <a:bodyPr/>
           <a:lstStyle/>
           <a:p>
+            <a:pPr marL="457200" lvl="1" indent="0">
+              <a:buNone/>
+            </a:pPr>
+            <a:r>
+              <a:rPr lang="es-ES" dirty="0"/>
+              <a:t>. </a:t>
+            </a:r>
+            <a:r>
+              <a:rPr lang="es-ES" b="1" dirty="0"/>
+              <a:t>Invierno</a:t>
+            </a:r>
+            <a:r>
+              <a:rPr lang="es-ES" dirty="0"/>
+              <a:t> - Campañas de salud, ergonomía, prevención de lesiones, vacunación</a:t>
+            </a:r>
+            <a:r>
+              <a:rPr lang="es-ES" b="1" dirty="0"/>
+              <a:t>.</a:t>
+            </a:r>
+          </a:p>
+          <a:p>
+            <a:pPr marL="457200" lvl="1" indent="0">
+              <a:buNone/>
+            </a:pPr>
             <a:endParaRPr lang="en-GB" dirty="0"/>
+          </a:p>
+          <a:p>
+            <a:pPr marL="457200" lvl="1" indent="0">
+              <a:buNone/>
+            </a:pPr>
+            <a:r>
+              <a:rPr lang="en-GB" dirty="0"/>
+              <a:t>. </a:t>
+            </a:r>
+            <a:r>
+              <a:rPr lang="en-GB" b="1" dirty="0"/>
+              <a:t>Meses </a:t>
+            </a:r>
+            <a:r>
+              <a:rPr lang="en-GB" b="1" dirty="0" err="1"/>
+              <a:t>pico</a:t>
+            </a:r>
+            <a:r>
+              <a:rPr lang="en-GB" b="1" dirty="0"/>
+              <a:t> (Marzo, Abril, Julio y </a:t>
+            </a:r>
+            <a:r>
+              <a:rPr lang="en-GB" b="1" dirty="0" err="1"/>
+              <a:t>Noviembre</a:t>
+            </a:r>
+            <a:r>
+              <a:rPr lang="en-GB" b="1" dirty="0"/>
+              <a:t>) </a:t>
+            </a:r>
+            <a:r>
+              <a:rPr lang="en-GB" dirty="0"/>
+              <a:t>- </a:t>
+            </a:r>
+            <a:r>
+              <a:rPr lang="en-GB" dirty="0" err="1"/>
+              <a:t>Redimensionar</a:t>
+            </a:r>
+            <a:r>
+              <a:rPr lang="en-GB" dirty="0"/>
+              <a:t> </a:t>
+            </a:r>
+            <a:r>
+              <a:rPr lang="en-GB" dirty="0" err="1"/>
+              <a:t>período</a:t>
+            </a:r>
+            <a:r>
+              <a:rPr lang="en-GB" dirty="0"/>
+              <a:t> </a:t>
+            </a:r>
+            <a:r>
+              <a:rPr lang="en-GB" dirty="0" err="1"/>
+              <a:t>vacacional</a:t>
+            </a:r>
+            <a:r>
+              <a:rPr lang="en-GB" dirty="0"/>
+              <a:t> </a:t>
+            </a:r>
+            <a:r>
+              <a:rPr lang="en-GB" dirty="0" err="1"/>
+              <a:t>acorde</a:t>
+            </a:r>
+            <a:r>
+              <a:rPr lang="en-GB" dirty="0"/>
+              <a:t> con </a:t>
+            </a:r>
+            <a:r>
+              <a:rPr lang="en-GB" dirty="0" err="1"/>
+              <a:t>los</a:t>
+            </a:r>
+            <a:r>
+              <a:rPr lang="en-GB" dirty="0"/>
+              <a:t> meses </a:t>
+            </a:r>
+            <a:r>
+              <a:rPr lang="en-GB" dirty="0" err="1"/>
+              <a:t>pico</a:t>
+            </a:r>
+            <a:r>
+              <a:rPr lang="en-GB" dirty="0"/>
+              <a:t> de </a:t>
+            </a:r>
+            <a:r>
+              <a:rPr lang="en-GB" dirty="0" err="1"/>
+              <a:t>ausentísmo</a:t>
+            </a:r>
+            <a:r>
+              <a:rPr lang="en-GB" dirty="0"/>
+              <a:t> (Marzo, Abril, Julio y Noviembe</a:t>
+            </a:r>
+          </a:p>
+          <a:p>
+            <a:pPr marL="457200" lvl="1" indent="0">
+              <a:buNone/>
+            </a:pPr>
+            <a:endParaRPr lang="en-GB" dirty="0"/>
+          </a:p>
+          <a:p>
+            <a:pPr marL="457200" lvl="1" indent="0">
+              <a:buNone/>
+            </a:pPr>
+            <a:r>
+              <a:rPr lang="en-GB" dirty="0"/>
+              <a:t>. </a:t>
+            </a:r>
+            <a:r>
+              <a:rPr lang="en-GB" b="1" dirty="0"/>
+              <a:t>Mayor </a:t>
+            </a:r>
+            <a:r>
+              <a:rPr lang="en-GB" b="1" dirty="0" err="1"/>
+              <a:t>acumulo</a:t>
+            </a:r>
+            <a:r>
+              <a:rPr lang="en-GB" b="1" dirty="0"/>
+              <a:t> de horas </a:t>
+            </a:r>
+            <a:r>
+              <a:rPr lang="en-GB" dirty="0"/>
+              <a:t>- </a:t>
+            </a:r>
+            <a:r>
+              <a:rPr lang="en-GB" dirty="0" err="1"/>
+              <a:t>Coordinación</a:t>
+            </a:r>
+            <a:r>
+              <a:rPr lang="en-GB" dirty="0"/>
+              <a:t> con </a:t>
+            </a:r>
+            <a:r>
+              <a:rPr lang="en-GB" dirty="0" err="1"/>
+              <a:t>servicios</a:t>
+            </a:r>
+            <a:r>
+              <a:rPr lang="en-GB" dirty="0"/>
+              <a:t> </a:t>
+            </a:r>
+            <a:r>
+              <a:rPr lang="en-GB" dirty="0" err="1"/>
+              <a:t>médicos</a:t>
+            </a:r>
+            <a:r>
+              <a:rPr lang="en-GB" dirty="0"/>
+              <a:t> para </a:t>
+            </a:r>
+            <a:r>
+              <a:rPr lang="en-GB" dirty="0" err="1"/>
+              <a:t>seguimiento</a:t>
+            </a:r>
+            <a:r>
+              <a:rPr lang="en-GB" dirty="0"/>
+              <a:t> </a:t>
+            </a:r>
+            <a:r>
+              <a:rPr lang="en-GB" dirty="0" err="1"/>
+              <a:t>temprano</a:t>
+            </a:r>
+            <a:r>
+              <a:rPr lang="en-GB" dirty="0"/>
+              <a:t> de </a:t>
+            </a:r>
+            <a:r>
+              <a:rPr lang="en-GB" dirty="0" err="1"/>
+              <a:t>casos</a:t>
+            </a:r>
+            <a:r>
+              <a:rPr lang="en-GB" dirty="0"/>
+              <a:t> &gt; 24h</a:t>
+            </a:r>
           </a:p>
         </p:txBody>
       </p:sp>
@@ -9127,18 +9336,13 @@
           <a:lstStyle/>
           <a:p>
             <a:r>
-              <a:rPr lang="en-US" dirty="0" err="1">
+              <a:rPr lang="en-US" dirty="0">
                 <a:solidFill>
                   <a:schemeClr val="bg1"/>
                 </a:solidFill>
               </a:rPr>
-              <a:t>Conclusiones</a:t>
-            </a:r>
-            <a:endParaRPr lang="en-US" dirty="0">
-              <a:solidFill>
-                <a:schemeClr val="bg1"/>
-              </a:solidFill>
-            </a:endParaRPr>
+              <a:t>KPIs</a:t>
+            </a:r>
           </a:p>
         </p:txBody>
       </p:sp>
@@ -9168,10 +9372,6 @@
           <a:bodyPr/>
           <a:lstStyle/>
           <a:p>
-            <a:r>
-              <a:rPr lang="en-US" dirty="0" err="1"/>
-              <a:t>xxxxxxxx</a:t>
-            </a:r>
             <a:endParaRPr lang="en-US" dirty="0"/>
           </a:p>
         </p:txBody>
@@ -9230,15 +9430,18 @@
         </p:nvSpPr>
         <p:spPr>
           <a:xfrm>
-            <a:off x="914400" y="731520"/>
-            <a:ext cx="4663440" cy="1737360"/>
+            <a:off x="529216" y="506667"/>
+            <a:ext cx="4463696" cy="692546"/>
           </a:xfrm>
         </p:spPr>
         <p:txBody>
           <a:bodyPr/>
           <a:lstStyle/>
           <a:p>
-            <a:endParaRPr lang="en-US" dirty="0"/>
+            <a:r>
+              <a:rPr lang="en-US" dirty="0"/>
+              <a:t>KPIs</a:t>
+            </a:r>
           </a:p>
         </p:txBody>
       </p:sp>
@@ -9260,14 +9463,50 @@
         </p:nvSpPr>
         <p:spPr>
           <a:xfrm>
-            <a:off x="5852160" y="731520"/>
-            <a:ext cx="5486400" cy="1737360"/>
+            <a:off x="598420" y="1722370"/>
+            <a:ext cx="4078512" cy="467693"/>
           </a:xfrm>
         </p:spPr>
         <p:txBody>
-          <a:bodyPr/>
+          <a:bodyPr>
+            <a:normAutofit/>
+          </a:bodyPr>
           <a:lstStyle/>
           <a:p>
+            <a:pPr marL="0" indent="0" algn="ctr">
+              <a:buNone/>
+            </a:pPr>
+            <a:r>
+              <a:rPr lang="en-US" b="1" dirty="0"/>
+              <a:t>% </a:t>
+            </a:r>
+            <a:r>
+              <a:rPr lang="en-US" b="1" dirty="0" err="1"/>
+              <a:t>Empleados</a:t>
+            </a:r>
+            <a:r>
+              <a:rPr lang="en-US" b="1" dirty="0"/>
+              <a:t> </a:t>
+            </a:r>
+            <a:r>
+              <a:rPr lang="en-US" b="1" dirty="0" err="1"/>
+              <a:t>ausentes</a:t>
+            </a:r>
+            <a:endParaRPr lang="en-US" b="1" dirty="0"/>
+          </a:p>
+          <a:p>
+            <a:endParaRPr lang="en-US" dirty="0"/>
+          </a:p>
+          <a:p>
+            <a:endParaRPr lang="en-US" dirty="0"/>
+          </a:p>
+          <a:p>
+            <a:endParaRPr lang="en-US" dirty="0"/>
+          </a:p>
+          <a:p>
+            <a:pPr marL="0" indent="0">
+              <a:buNone/>
+            </a:pPr>
             <a:endParaRPr lang="en-US" dirty="0"/>
           </a:p>
         </p:txBody>
@@ -9487,26 +9726,878 @@
       </p:sp>
       <p:sp>
         <p:nvSpPr>
-          <p:cNvPr id="5" name="Content Placeholder 4">
-            <a:extLst>
-              <a:ext uri="{FF2B5EF4-FFF2-40B4-BE49-F238E27FC236}">
-                <a16:creationId xmlns:a16="http://schemas.microsoft.com/office/drawing/2014/main" id="{68E02865-2722-71C6-B58E-F92A2A4DCBA1}"/>
-              </a:ext>
-            </a:extLst>
-          </p:cNvPr>
-          <p:cNvSpPr>
-            <a:spLocks noGrp="1"/>
-          </p:cNvSpPr>
-          <p:nvPr>
-            <p:ph idx="30"/>
-          </p:nvPr>
-        </p:nvSpPr>
-        <p:spPr/>
-        <p:txBody>
-          <a:bodyPr/>
+          <p:cNvPr id="4" name="Hexagon 3">
+            <a:extLst>
+              <a:ext uri="{FF2B5EF4-FFF2-40B4-BE49-F238E27FC236}">
+                <a16:creationId xmlns:a16="http://schemas.microsoft.com/office/drawing/2014/main" id="{01F53177-39F7-A239-33CD-3B0260322C63}"/>
+              </a:ext>
+            </a:extLst>
+          </p:cNvPr>
+          <p:cNvSpPr/>
+          <p:nvPr/>
+        </p:nvSpPr>
+        <p:spPr>
+          <a:xfrm>
+            <a:off x="2200808" y="2312233"/>
+            <a:ext cx="1280410" cy="1083039"/>
+          </a:xfrm>
+          <a:prstGeom prst="hexagon">
+            <a:avLst/>
+          </a:prstGeom>
+        </p:spPr>
+        <p:style>
+          <a:lnRef idx="2">
+            <a:schemeClr val="accent1">
+              <a:shade val="15000"/>
+            </a:schemeClr>
+          </a:lnRef>
+          <a:fillRef idx="1">
+            <a:schemeClr val="accent1"/>
+          </a:fillRef>
+          <a:effectRef idx="0">
+            <a:schemeClr val="accent1"/>
+          </a:effectRef>
+          <a:fontRef idx="minor">
+            <a:schemeClr val="lt1"/>
+          </a:fontRef>
+        </p:style>
+        <p:txBody>
+          <a:bodyPr rtlCol="0" anchor="ctr"/>
           <a:lstStyle/>
           <a:p>
-            <a:endParaRPr lang="en-GB"/>
+            <a:pPr algn="ctr"/>
+            <a:r>
+              <a:rPr lang="es-ES" dirty="0"/>
+              <a:t>91.67%</a:t>
+            </a:r>
+            <a:endParaRPr lang="en-GB" dirty="0"/>
+          </a:p>
+        </p:txBody>
+      </p:sp>
+      <p:sp>
+        <p:nvSpPr>
+          <p:cNvPr id="9" name="Content Placeholder 9">
+            <a:extLst>
+              <a:ext uri="{FF2B5EF4-FFF2-40B4-BE49-F238E27FC236}">
+                <a16:creationId xmlns:a16="http://schemas.microsoft.com/office/drawing/2014/main" id="{D4EDED24-0D6F-E763-C7E6-094DBD036F12}"/>
+              </a:ext>
+            </a:extLst>
+          </p:cNvPr>
+          <p:cNvSpPr txBox="1">
+            <a:spLocks/>
+          </p:cNvSpPr>
+          <p:nvPr/>
+        </p:nvSpPr>
+        <p:spPr>
+          <a:xfrm>
+            <a:off x="5972297" y="1661284"/>
+            <a:ext cx="4263953" cy="589863"/>
+          </a:xfrm>
+          <a:prstGeom prst="rect">
+            <a:avLst/>
+          </a:prstGeom>
+        </p:spPr>
+        <p:txBody>
+          <a:bodyPr vert="horz" lIns="91440" tIns="45720" rIns="91440" bIns="45720" rtlCol="0">
+            <a:normAutofit/>
+          </a:bodyPr>
+          <a:lstStyle>
+            <a:lvl1pPr marL="228600" indent="-228600" algn="l" defTabSz="914400" rtl="0" eaLnBrk="1" latinLnBrk="0" hangingPunct="1">
+              <a:lnSpc>
+                <a:spcPct val="90000"/>
+              </a:lnSpc>
+              <a:spcBef>
+                <a:spcPts val="1000"/>
+              </a:spcBef>
+              <a:buFont typeface="Arial" panose="020B0604020202020204" pitchFamily="34" charset="0"/>
+              <a:buChar char="•"/>
+              <a:defRPr sz="1800" kern="1200">
+                <a:solidFill>
+                  <a:schemeClr val="tx1"/>
+                </a:solidFill>
+                <a:latin typeface="+mn-lt"/>
+                <a:ea typeface="+mn-ea"/>
+                <a:cs typeface="+mn-cs"/>
+              </a:defRPr>
+            </a:lvl1pPr>
+            <a:lvl2pPr marL="685800" indent="-228600" algn="l" defTabSz="914400" rtl="0" eaLnBrk="1" latinLnBrk="0" hangingPunct="1">
+              <a:lnSpc>
+                <a:spcPct val="90000"/>
+              </a:lnSpc>
+              <a:spcBef>
+                <a:spcPts val="500"/>
+              </a:spcBef>
+              <a:buFont typeface="Arial" panose="020B0604020202020204" pitchFamily="34" charset="0"/>
+              <a:buChar char="•"/>
+              <a:defRPr sz="1800" kern="1200">
+                <a:solidFill>
+                  <a:schemeClr val="tx1"/>
+                </a:solidFill>
+                <a:latin typeface="+mn-lt"/>
+                <a:ea typeface="+mn-ea"/>
+                <a:cs typeface="+mn-cs"/>
+              </a:defRPr>
+            </a:lvl2pPr>
+            <a:lvl3pPr marL="1143000" indent="-228600" algn="l" defTabSz="914400" rtl="0" eaLnBrk="1" latinLnBrk="0" hangingPunct="1">
+              <a:lnSpc>
+                <a:spcPct val="90000"/>
+              </a:lnSpc>
+              <a:spcBef>
+                <a:spcPts val="500"/>
+              </a:spcBef>
+              <a:buFont typeface="Arial" panose="020B0604020202020204" pitchFamily="34" charset="0"/>
+              <a:buChar char="•"/>
+              <a:defRPr sz="1800" kern="1200">
+                <a:solidFill>
+                  <a:schemeClr val="tx1"/>
+                </a:solidFill>
+                <a:latin typeface="+mn-lt"/>
+                <a:ea typeface="+mn-ea"/>
+                <a:cs typeface="+mn-cs"/>
+              </a:defRPr>
+            </a:lvl3pPr>
+            <a:lvl4pPr marL="1600200" indent="-228600" algn="l" defTabSz="914400" rtl="0" eaLnBrk="1" latinLnBrk="0" hangingPunct="1">
+              <a:lnSpc>
+                <a:spcPct val="90000"/>
+              </a:lnSpc>
+              <a:spcBef>
+                <a:spcPts val="500"/>
+              </a:spcBef>
+              <a:buFont typeface="Arial" panose="020B0604020202020204" pitchFamily="34" charset="0"/>
+              <a:buChar char="•"/>
+              <a:defRPr sz="1800" kern="1200">
+                <a:solidFill>
+                  <a:schemeClr val="tx1"/>
+                </a:solidFill>
+                <a:latin typeface="+mn-lt"/>
+                <a:ea typeface="+mn-ea"/>
+                <a:cs typeface="+mn-cs"/>
+              </a:defRPr>
+            </a:lvl4pPr>
+            <a:lvl5pPr marL="2057400" indent="-228600" algn="l" defTabSz="914400" rtl="0" eaLnBrk="1" latinLnBrk="0" hangingPunct="1">
+              <a:lnSpc>
+                <a:spcPct val="90000"/>
+              </a:lnSpc>
+              <a:spcBef>
+                <a:spcPts val="500"/>
+              </a:spcBef>
+              <a:buFont typeface="Arial" panose="020B0604020202020204" pitchFamily="34" charset="0"/>
+              <a:buChar char="•"/>
+              <a:defRPr sz="1800" kern="1200">
+                <a:solidFill>
+                  <a:schemeClr val="tx1"/>
+                </a:solidFill>
+                <a:latin typeface="+mn-lt"/>
+                <a:ea typeface="+mn-ea"/>
+                <a:cs typeface="+mn-cs"/>
+              </a:defRPr>
+            </a:lvl5pPr>
+            <a:lvl6pPr marL="2514600" indent="-228600" algn="l" defTabSz="914400" rtl="0" eaLnBrk="1" latinLnBrk="0" hangingPunct="1">
+              <a:lnSpc>
+                <a:spcPct val="90000"/>
+              </a:lnSpc>
+              <a:spcBef>
+                <a:spcPts val="500"/>
+              </a:spcBef>
+              <a:buFont typeface="Arial" panose="020B0604020202020204" pitchFamily="34" charset="0"/>
+              <a:buChar char="•"/>
+              <a:defRPr sz="1800" kern="1200">
+                <a:solidFill>
+                  <a:schemeClr val="tx1"/>
+                </a:solidFill>
+                <a:latin typeface="+mn-lt"/>
+                <a:ea typeface="+mn-ea"/>
+                <a:cs typeface="+mn-cs"/>
+              </a:defRPr>
+            </a:lvl6pPr>
+            <a:lvl7pPr marL="2971800" indent="-228600" algn="l" defTabSz="914400" rtl="0" eaLnBrk="1" latinLnBrk="0" hangingPunct="1">
+              <a:lnSpc>
+                <a:spcPct val="90000"/>
+              </a:lnSpc>
+              <a:spcBef>
+                <a:spcPts val="500"/>
+              </a:spcBef>
+              <a:buFont typeface="Arial" panose="020B0604020202020204" pitchFamily="34" charset="0"/>
+              <a:buChar char="•"/>
+              <a:defRPr sz="1800" kern="1200">
+                <a:solidFill>
+                  <a:schemeClr val="tx1"/>
+                </a:solidFill>
+                <a:latin typeface="+mn-lt"/>
+                <a:ea typeface="+mn-ea"/>
+                <a:cs typeface="+mn-cs"/>
+              </a:defRPr>
+            </a:lvl7pPr>
+            <a:lvl8pPr marL="3429000" indent="-228600" algn="l" defTabSz="914400" rtl="0" eaLnBrk="1" latinLnBrk="0" hangingPunct="1">
+              <a:lnSpc>
+                <a:spcPct val="90000"/>
+              </a:lnSpc>
+              <a:spcBef>
+                <a:spcPts val="500"/>
+              </a:spcBef>
+              <a:buFont typeface="Arial" panose="020B0604020202020204" pitchFamily="34" charset="0"/>
+              <a:buChar char="•"/>
+              <a:defRPr sz="1800" kern="1200">
+                <a:solidFill>
+                  <a:schemeClr val="tx1"/>
+                </a:solidFill>
+                <a:latin typeface="+mn-lt"/>
+                <a:ea typeface="+mn-ea"/>
+                <a:cs typeface="+mn-cs"/>
+              </a:defRPr>
+            </a:lvl8pPr>
+            <a:lvl9pPr marL="3886200" indent="-228600" algn="l" defTabSz="914400" rtl="0" eaLnBrk="1" latinLnBrk="0" hangingPunct="1">
+              <a:lnSpc>
+                <a:spcPct val="90000"/>
+              </a:lnSpc>
+              <a:spcBef>
+                <a:spcPts val="500"/>
+              </a:spcBef>
+              <a:buFont typeface="Arial" panose="020B0604020202020204" pitchFamily="34" charset="0"/>
+              <a:buChar char="•"/>
+              <a:defRPr sz="1800" kern="1200">
+                <a:solidFill>
+                  <a:schemeClr val="tx1"/>
+                </a:solidFill>
+                <a:latin typeface="+mn-lt"/>
+                <a:ea typeface="+mn-ea"/>
+                <a:cs typeface="+mn-cs"/>
+              </a:defRPr>
+            </a:lvl9pPr>
+          </a:lstStyle>
+          <a:p>
+            <a:pPr marL="0" indent="0" algn="ctr">
+              <a:buNone/>
+            </a:pPr>
+            <a:r>
+              <a:rPr lang="en-US" b="1" dirty="0"/>
+              <a:t>Mes </a:t>
+            </a:r>
+            <a:r>
+              <a:rPr lang="en-US" b="1" dirty="0" err="1"/>
+              <a:t>pico</a:t>
+            </a:r>
+            <a:r>
+              <a:rPr lang="en-US" b="1" dirty="0"/>
+              <a:t> carga </a:t>
+            </a:r>
+            <a:r>
+              <a:rPr lang="en-US" b="1" dirty="0" err="1"/>
+              <a:t>ausencia</a:t>
+            </a:r>
+            <a:endParaRPr lang="en-US" b="1" dirty="0"/>
+          </a:p>
+          <a:p>
+            <a:pPr algn="ctr"/>
+            <a:endParaRPr lang="en-US" b="1" dirty="0"/>
+          </a:p>
+          <a:p>
+            <a:endParaRPr lang="en-US" dirty="0"/>
+          </a:p>
+        </p:txBody>
+      </p:sp>
+      <p:sp>
+        <p:nvSpPr>
+          <p:cNvPr id="11" name="Rectangle 10">
+            <a:extLst>
+              <a:ext uri="{FF2B5EF4-FFF2-40B4-BE49-F238E27FC236}">
+                <a16:creationId xmlns:a16="http://schemas.microsoft.com/office/drawing/2014/main" id="{55F28533-E21A-7FD1-BD00-211ED959FF57}"/>
+              </a:ext>
+            </a:extLst>
+          </p:cNvPr>
+          <p:cNvSpPr/>
+          <p:nvPr/>
+        </p:nvSpPr>
+        <p:spPr>
+          <a:xfrm>
+            <a:off x="7328317" y="2345961"/>
+            <a:ext cx="1282283" cy="1083039"/>
+          </a:xfrm>
+          <a:prstGeom prst="rect">
+            <a:avLst/>
+          </a:prstGeom>
+        </p:spPr>
+        <p:style>
+          <a:lnRef idx="2">
+            <a:schemeClr val="accent1">
+              <a:shade val="15000"/>
+            </a:schemeClr>
+          </a:lnRef>
+          <a:fillRef idx="1">
+            <a:schemeClr val="accent1"/>
+          </a:fillRef>
+          <a:effectRef idx="0">
+            <a:schemeClr val="accent1"/>
+          </a:effectRef>
+          <a:fontRef idx="minor">
+            <a:schemeClr val="lt1"/>
+          </a:fontRef>
+        </p:style>
+        <p:txBody>
+          <a:bodyPr rtlCol="0" anchor="ctr"/>
+          <a:lstStyle/>
+          <a:p>
+            <a:pPr algn="ctr"/>
+            <a:r>
+              <a:rPr lang="es-ES" dirty="0"/>
+              <a:t>Marzo </a:t>
+            </a:r>
+          </a:p>
+          <a:p>
+            <a:pPr algn="ctr"/>
+            <a:r>
+              <a:rPr lang="es-ES" dirty="0"/>
+              <a:t>755 horas</a:t>
+            </a:r>
+            <a:endParaRPr lang="en-GB" dirty="0"/>
+          </a:p>
+        </p:txBody>
+      </p:sp>
+      <p:sp>
+        <p:nvSpPr>
+          <p:cNvPr id="12" name="Content Placeholder 9">
+            <a:extLst>
+              <a:ext uri="{FF2B5EF4-FFF2-40B4-BE49-F238E27FC236}">
+                <a16:creationId xmlns:a16="http://schemas.microsoft.com/office/drawing/2014/main" id="{3742BE1F-0F1E-7F40-18C2-BA07939C6904}"/>
+              </a:ext>
+            </a:extLst>
+          </p:cNvPr>
+          <p:cNvSpPr txBox="1">
+            <a:spLocks/>
+          </p:cNvSpPr>
+          <p:nvPr/>
+        </p:nvSpPr>
+        <p:spPr>
+          <a:xfrm>
+            <a:off x="801757" y="4050717"/>
+            <a:ext cx="4078512" cy="731147"/>
+          </a:xfrm>
+          <a:prstGeom prst="rect">
+            <a:avLst/>
+          </a:prstGeom>
+        </p:spPr>
+        <p:txBody>
+          <a:bodyPr vert="horz" lIns="91440" tIns="45720" rIns="91440" bIns="45720" rtlCol="0">
+            <a:normAutofit/>
+          </a:bodyPr>
+          <a:lstStyle>
+            <a:lvl1pPr marL="228600" indent="-228600" algn="l" defTabSz="914400" rtl="0" eaLnBrk="1" latinLnBrk="0" hangingPunct="1">
+              <a:lnSpc>
+                <a:spcPct val="90000"/>
+              </a:lnSpc>
+              <a:spcBef>
+                <a:spcPts val="1000"/>
+              </a:spcBef>
+              <a:buFont typeface="Arial" panose="020B0604020202020204" pitchFamily="34" charset="0"/>
+              <a:buChar char="•"/>
+              <a:defRPr sz="1800" kern="1200">
+                <a:solidFill>
+                  <a:schemeClr val="tx1"/>
+                </a:solidFill>
+                <a:latin typeface="+mn-lt"/>
+                <a:ea typeface="+mn-ea"/>
+                <a:cs typeface="+mn-cs"/>
+              </a:defRPr>
+            </a:lvl1pPr>
+            <a:lvl2pPr marL="685800" indent="-228600" algn="l" defTabSz="914400" rtl="0" eaLnBrk="1" latinLnBrk="0" hangingPunct="1">
+              <a:lnSpc>
+                <a:spcPct val="90000"/>
+              </a:lnSpc>
+              <a:spcBef>
+                <a:spcPts val="500"/>
+              </a:spcBef>
+              <a:buFont typeface="Arial" panose="020B0604020202020204" pitchFamily="34" charset="0"/>
+              <a:buChar char="•"/>
+              <a:defRPr sz="1800" kern="1200">
+                <a:solidFill>
+                  <a:schemeClr val="tx1"/>
+                </a:solidFill>
+                <a:latin typeface="+mn-lt"/>
+                <a:ea typeface="+mn-ea"/>
+                <a:cs typeface="+mn-cs"/>
+              </a:defRPr>
+            </a:lvl2pPr>
+            <a:lvl3pPr marL="1143000" indent="-228600" algn="l" defTabSz="914400" rtl="0" eaLnBrk="1" latinLnBrk="0" hangingPunct="1">
+              <a:lnSpc>
+                <a:spcPct val="90000"/>
+              </a:lnSpc>
+              <a:spcBef>
+                <a:spcPts val="500"/>
+              </a:spcBef>
+              <a:buFont typeface="Arial" panose="020B0604020202020204" pitchFamily="34" charset="0"/>
+              <a:buChar char="•"/>
+              <a:defRPr sz="1800" kern="1200">
+                <a:solidFill>
+                  <a:schemeClr val="tx1"/>
+                </a:solidFill>
+                <a:latin typeface="+mn-lt"/>
+                <a:ea typeface="+mn-ea"/>
+                <a:cs typeface="+mn-cs"/>
+              </a:defRPr>
+            </a:lvl3pPr>
+            <a:lvl4pPr marL="1600200" indent="-228600" algn="l" defTabSz="914400" rtl="0" eaLnBrk="1" latinLnBrk="0" hangingPunct="1">
+              <a:lnSpc>
+                <a:spcPct val="90000"/>
+              </a:lnSpc>
+              <a:spcBef>
+                <a:spcPts val="500"/>
+              </a:spcBef>
+              <a:buFont typeface="Arial" panose="020B0604020202020204" pitchFamily="34" charset="0"/>
+              <a:buChar char="•"/>
+              <a:defRPr sz="1800" kern="1200">
+                <a:solidFill>
+                  <a:schemeClr val="tx1"/>
+                </a:solidFill>
+                <a:latin typeface="+mn-lt"/>
+                <a:ea typeface="+mn-ea"/>
+                <a:cs typeface="+mn-cs"/>
+              </a:defRPr>
+            </a:lvl4pPr>
+            <a:lvl5pPr marL="2057400" indent="-228600" algn="l" defTabSz="914400" rtl="0" eaLnBrk="1" latinLnBrk="0" hangingPunct="1">
+              <a:lnSpc>
+                <a:spcPct val="90000"/>
+              </a:lnSpc>
+              <a:spcBef>
+                <a:spcPts val="500"/>
+              </a:spcBef>
+              <a:buFont typeface="Arial" panose="020B0604020202020204" pitchFamily="34" charset="0"/>
+              <a:buChar char="•"/>
+              <a:defRPr sz="1800" kern="1200">
+                <a:solidFill>
+                  <a:schemeClr val="tx1"/>
+                </a:solidFill>
+                <a:latin typeface="+mn-lt"/>
+                <a:ea typeface="+mn-ea"/>
+                <a:cs typeface="+mn-cs"/>
+              </a:defRPr>
+            </a:lvl5pPr>
+            <a:lvl6pPr marL="2514600" indent="-228600" algn="l" defTabSz="914400" rtl="0" eaLnBrk="1" latinLnBrk="0" hangingPunct="1">
+              <a:lnSpc>
+                <a:spcPct val="90000"/>
+              </a:lnSpc>
+              <a:spcBef>
+                <a:spcPts val="500"/>
+              </a:spcBef>
+              <a:buFont typeface="Arial" panose="020B0604020202020204" pitchFamily="34" charset="0"/>
+              <a:buChar char="•"/>
+              <a:defRPr sz="1800" kern="1200">
+                <a:solidFill>
+                  <a:schemeClr val="tx1"/>
+                </a:solidFill>
+                <a:latin typeface="+mn-lt"/>
+                <a:ea typeface="+mn-ea"/>
+                <a:cs typeface="+mn-cs"/>
+              </a:defRPr>
+            </a:lvl6pPr>
+            <a:lvl7pPr marL="2971800" indent="-228600" algn="l" defTabSz="914400" rtl="0" eaLnBrk="1" latinLnBrk="0" hangingPunct="1">
+              <a:lnSpc>
+                <a:spcPct val="90000"/>
+              </a:lnSpc>
+              <a:spcBef>
+                <a:spcPts val="500"/>
+              </a:spcBef>
+              <a:buFont typeface="Arial" panose="020B0604020202020204" pitchFamily="34" charset="0"/>
+              <a:buChar char="•"/>
+              <a:defRPr sz="1800" kern="1200">
+                <a:solidFill>
+                  <a:schemeClr val="tx1"/>
+                </a:solidFill>
+                <a:latin typeface="+mn-lt"/>
+                <a:ea typeface="+mn-ea"/>
+                <a:cs typeface="+mn-cs"/>
+              </a:defRPr>
+            </a:lvl7pPr>
+            <a:lvl8pPr marL="3429000" indent="-228600" algn="l" defTabSz="914400" rtl="0" eaLnBrk="1" latinLnBrk="0" hangingPunct="1">
+              <a:lnSpc>
+                <a:spcPct val="90000"/>
+              </a:lnSpc>
+              <a:spcBef>
+                <a:spcPts val="500"/>
+              </a:spcBef>
+              <a:buFont typeface="Arial" panose="020B0604020202020204" pitchFamily="34" charset="0"/>
+              <a:buChar char="•"/>
+              <a:defRPr sz="1800" kern="1200">
+                <a:solidFill>
+                  <a:schemeClr val="tx1"/>
+                </a:solidFill>
+                <a:latin typeface="+mn-lt"/>
+                <a:ea typeface="+mn-ea"/>
+                <a:cs typeface="+mn-cs"/>
+              </a:defRPr>
+            </a:lvl8pPr>
+            <a:lvl9pPr marL="3886200" indent="-228600" algn="l" defTabSz="914400" rtl="0" eaLnBrk="1" latinLnBrk="0" hangingPunct="1">
+              <a:lnSpc>
+                <a:spcPct val="90000"/>
+              </a:lnSpc>
+              <a:spcBef>
+                <a:spcPts val="500"/>
+              </a:spcBef>
+              <a:buFont typeface="Arial" panose="020B0604020202020204" pitchFamily="34" charset="0"/>
+              <a:buChar char="•"/>
+              <a:defRPr sz="1800" kern="1200">
+                <a:solidFill>
+                  <a:schemeClr val="tx1"/>
+                </a:solidFill>
+                <a:latin typeface="+mn-lt"/>
+                <a:ea typeface="+mn-ea"/>
+                <a:cs typeface="+mn-cs"/>
+              </a:defRPr>
+            </a:lvl9pPr>
+          </a:lstStyle>
+          <a:p>
+            <a:pPr marL="0" indent="0" algn="ctr">
+              <a:buNone/>
+            </a:pPr>
+            <a:r>
+              <a:rPr lang="en-US" b="1" dirty="0" err="1"/>
+              <a:t>Motivo</a:t>
+            </a:r>
+            <a:r>
+              <a:rPr lang="en-US" b="1" dirty="0"/>
+              <a:t> Modal</a:t>
+            </a:r>
+          </a:p>
+        </p:txBody>
+      </p:sp>
+      <p:sp>
+        <p:nvSpPr>
+          <p:cNvPr id="13" name="Content Placeholder 9">
+            <a:extLst>
+              <a:ext uri="{FF2B5EF4-FFF2-40B4-BE49-F238E27FC236}">
+                <a16:creationId xmlns:a16="http://schemas.microsoft.com/office/drawing/2014/main" id="{853AF8A3-DBD5-D710-5706-36F80DB2CF6B}"/>
+              </a:ext>
+            </a:extLst>
+          </p:cNvPr>
+          <p:cNvSpPr txBox="1">
+            <a:spLocks/>
+          </p:cNvSpPr>
+          <p:nvPr/>
+        </p:nvSpPr>
+        <p:spPr>
+          <a:xfrm>
+            <a:off x="6030384" y="4082123"/>
+            <a:ext cx="4772055" cy="731147"/>
+          </a:xfrm>
+          <a:prstGeom prst="rect">
+            <a:avLst/>
+          </a:prstGeom>
+        </p:spPr>
+        <p:txBody>
+          <a:bodyPr vert="horz" lIns="91440" tIns="45720" rIns="91440" bIns="45720" rtlCol="0">
+            <a:normAutofit/>
+          </a:bodyPr>
+          <a:lstStyle>
+            <a:lvl1pPr marL="228600" indent="-228600" algn="l" defTabSz="914400" rtl="0" eaLnBrk="1" latinLnBrk="0" hangingPunct="1">
+              <a:lnSpc>
+                <a:spcPct val="90000"/>
+              </a:lnSpc>
+              <a:spcBef>
+                <a:spcPts val="1000"/>
+              </a:spcBef>
+              <a:buFont typeface="Arial" panose="020B0604020202020204" pitchFamily="34" charset="0"/>
+              <a:buChar char="•"/>
+              <a:defRPr sz="1800" kern="1200">
+                <a:solidFill>
+                  <a:schemeClr val="tx1"/>
+                </a:solidFill>
+                <a:latin typeface="+mn-lt"/>
+                <a:ea typeface="+mn-ea"/>
+                <a:cs typeface="+mn-cs"/>
+              </a:defRPr>
+            </a:lvl1pPr>
+            <a:lvl2pPr marL="685800" indent="-228600" algn="l" defTabSz="914400" rtl="0" eaLnBrk="1" latinLnBrk="0" hangingPunct="1">
+              <a:lnSpc>
+                <a:spcPct val="90000"/>
+              </a:lnSpc>
+              <a:spcBef>
+                <a:spcPts val="500"/>
+              </a:spcBef>
+              <a:buFont typeface="Arial" panose="020B0604020202020204" pitchFamily="34" charset="0"/>
+              <a:buChar char="•"/>
+              <a:defRPr sz="1800" kern="1200">
+                <a:solidFill>
+                  <a:schemeClr val="tx1"/>
+                </a:solidFill>
+                <a:latin typeface="+mn-lt"/>
+                <a:ea typeface="+mn-ea"/>
+                <a:cs typeface="+mn-cs"/>
+              </a:defRPr>
+            </a:lvl2pPr>
+            <a:lvl3pPr marL="1143000" indent="-228600" algn="l" defTabSz="914400" rtl="0" eaLnBrk="1" latinLnBrk="0" hangingPunct="1">
+              <a:lnSpc>
+                <a:spcPct val="90000"/>
+              </a:lnSpc>
+              <a:spcBef>
+                <a:spcPts val="500"/>
+              </a:spcBef>
+              <a:buFont typeface="Arial" panose="020B0604020202020204" pitchFamily="34" charset="0"/>
+              <a:buChar char="•"/>
+              <a:defRPr sz="1800" kern="1200">
+                <a:solidFill>
+                  <a:schemeClr val="tx1"/>
+                </a:solidFill>
+                <a:latin typeface="+mn-lt"/>
+                <a:ea typeface="+mn-ea"/>
+                <a:cs typeface="+mn-cs"/>
+              </a:defRPr>
+            </a:lvl3pPr>
+            <a:lvl4pPr marL="1600200" indent="-228600" algn="l" defTabSz="914400" rtl="0" eaLnBrk="1" latinLnBrk="0" hangingPunct="1">
+              <a:lnSpc>
+                <a:spcPct val="90000"/>
+              </a:lnSpc>
+              <a:spcBef>
+                <a:spcPts val="500"/>
+              </a:spcBef>
+              <a:buFont typeface="Arial" panose="020B0604020202020204" pitchFamily="34" charset="0"/>
+              <a:buChar char="•"/>
+              <a:defRPr sz="1800" kern="1200">
+                <a:solidFill>
+                  <a:schemeClr val="tx1"/>
+                </a:solidFill>
+                <a:latin typeface="+mn-lt"/>
+                <a:ea typeface="+mn-ea"/>
+                <a:cs typeface="+mn-cs"/>
+              </a:defRPr>
+            </a:lvl4pPr>
+            <a:lvl5pPr marL="2057400" indent="-228600" algn="l" defTabSz="914400" rtl="0" eaLnBrk="1" latinLnBrk="0" hangingPunct="1">
+              <a:lnSpc>
+                <a:spcPct val="90000"/>
+              </a:lnSpc>
+              <a:spcBef>
+                <a:spcPts val="500"/>
+              </a:spcBef>
+              <a:buFont typeface="Arial" panose="020B0604020202020204" pitchFamily="34" charset="0"/>
+              <a:buChar char="•"/>
+              <a:defRPr sz="1800" kern="1200">
+                <a:solidFill>
+                  <a:schemeClr val="tx1"/>
+                </a:solidFill>
+                <a:latin typeface="+mn-lt"/>
+                <a:ea typeface="+mn-ea"/>
+                <a:cs typeface="+mn-cs"/>
+              </a:defRPr>
+            </a:lvl5pPr>
+            <a:lvl6pPr marL="2514600" indent="-228600" algn="l" defTabSz="914400" rtl="0" eaLnBrk="1" latinLnBrk="0" hangingPunct="1">
+              <a:lnSpc>
+                <a:spcPct val="90000"/>
+              </a:lnSpc>
+              <a:spcBef>
+                <a:spcPts val="500"/>
+              </a:spcBef>
+              <a:buFont typeface="Arial" panose="020B0604020202020204" pitchFamily="34" charset="0"/>
+              <a:buChar char="•"/>
+              <a:defRPr sz="1800" kern="1200">
+                <a:solidFill>
+                  <a:schemeClr val="tx1"/>
+                </a:solidFill>
+                <a:latin typeface="+mn-lt"/>
+                <a:ea typeface="+mn-ea"/>
+                <a:cs typeface="+mn-cs"/>
+              </a:defRPr>
+            </a:lvl6pPr>
+            <a:lvl7pPr marL="2971800" indent="-228600" algn="l" defTabSz="914400" rtl="0" eaLnBrk="1" latinLnBrk="0" hangingPunct="1">
+              <a:lnSpc>
+                <a:spcPct val="90000"/>
+              </a:lnSpc>
+              <a:spcBef>
+                <a:spcPts val="500"/>
+              </a:spcBef>
+              <a:buFont typeface="Arial" panose="020B0604020202020204" pitchFamily="34" charset="0"/>
+              <a:buChar char="•"/>
+              <a:defRPr sz="1800" kern="1200">
+                <a:solidFill>
+                  <a:schemeClr val="tx1"/>
+                </a:solidFill>
+                <a:latin typeface="+mn-lt"/>
+                <a:ea typeface="+mn-ea"/>
+                <a:cs typeface="+mn-cs"/>
+              </a:defRPr>
+            </a:lvl7pPr>
+            <a:lvl8pPr marL="3429000" indent="-228600" algn="l" defTabSz="914400" rtl="0" eaLnBrk="1" latinLnBrk="0" hangingPunct="1">
+              <a:lnSpc>
+                <a:spcPct val="90000"/>
+              </a:lnSpc>
+              <a:spcBef>
+                <a:spcPts val="500"/>
+              </a:spcBef>
+              <a:buFont typeface="Arial" panose="020B0604020202020204" pitchFamily="34" charset="0"/>
+              <a:buChar char="•"/>
+              <a:defRPr sz="1800" kern="1200">
+                <a:solidFill>
+                  <a:schemeClr val="tx1"/>
+                </a:solidFill>
+                <a:latin typeface="+mn-lt"/>
+                <a:ea typeface="+mn-ea"/>
+                <a:cs typeface="+mn-cs"/>
+              </a:defRPr>
+            </a:lvl8pPr>
+            <a:lvl9pPr marL="3886200" indent="-228600" algn="l" defTabSz="914400" rtl="0" eaLnBrk="1" latinLnBrk="0" hangingPunct="1">
+              <a:lnSpc>
+                <a:spcPct val="90000"/>
+              </a:lnSpc>
+              <a:spcBef>
+                <a:spcPts val="500"/>
+              </a:spcBef>
+              <a:buFont typeface="Arial" panose="020B0604020202020204" pitchFamily="34" charset="0"/>
+              <a:buChar char="•"/>
+              <a:defRPr sz="1800" kern="1200">
+                <a:solidFill>
+                  <a:schemeClr val="tx1"/>
+                </a:solidFill>
+                <a:latin typeface="+mn-lt"/>
+                <a:ea typeface="+mn-ea"/>
+                <a:cs typeface="+mn-cs"/>
+              </a:defRPr>
+            </a:lvl9pPr>
+          </a:lstStyle>
+          <a:p>
+            <a:pPr marL="0" indent="0">
+              <a:buNone/>
+            </a:pPr>
+            <a:r>
+              <a:rPr lang="en-US" b="1" dirty="0" err="1"/>
+              <a:t>Indice</a:t>
+            </a:r>
+            <a:r>
+              <a:rPr lang="en-US" b="1" dirty="0"/>
+              <a:t> </a:t>
+            </a:r>
+            <a:r>
+              <a:rPr lang="en-US" b="1" dirty="0" err="1"/>
+              <a:t>Eficiencia</a:t>
+            </a:r>
+            <a:r>
+              <a:rPr lang="en-US" b="1" dirty="0"/>
+              <a:t> </a:t>
+            </a:r>
+            <a:r>
+              <a:rPr lang="en-US" b="1" dirty="0" err="1"/>
+              <a:t>relativa</a:t>
+            </a:r>
+            <a:r>
+              <a:rPr lang="en-US" b="1" dirty="0"/>
+              <a:t> carga </a:t>
+            </a:r>
+            <a:r>
+              <a:rPr lang="en-US" b="1" dirty="0" err="1"/>
+              <a:t>laboral</a:t>
+            </a:r>
+            <a:endParaRPr lang="en-US" b="1" dirty="0"/>
+          </a:p>
+        </p:txBody>
+      </p:sp>
+      <p:sp>
+        <p:nvSpPr>
+          <p:cNvPr id="14" name="Rectangle 13">
+            <a:extLst>
+              <a:ext uri="{FF2B5EF4-FFF2-40B4-BE49-F238E27FC236}">
+                <a16:creationId xmlns:a16="http://schemas.microsoft.com/office/drawing/2014/main" id="{80625F6E-D523-8C5A-9383-8290B01EB7CC}"/>
+              </a:ext>
+            </a:extLst>
+          </p:cNvPr>
+          <p:cNvSpPr/>
+          <p:nvPr/>
+        </p:nvSpPr>
+        <p:spPr>
+          <a:xfrm>
+            <a:off x="1302958" y="4966617"/>
+            <a:ext cx="4078511" cy="1083039"/>
+          </a:xfrm>
+          <a:prstGeom prst="rect">
+            <a:avLst/>
+          </a:prstGeom>
+        </p:spPr>
+        <p:style>
+          <a:lnRef idx="2">
+            <a:schemeClr val="accent1">
+              <a:shade val="15000"/>
+            </a:schemeClr>
+          </a:lnRef>
+          <a:fillRef idx="1">
+            <a:schemeClr val="accent1"/>
+          </a:fillRef>
+          <a:effectRef idx="0">
+            <a:schemeClr val="accent1"/>
+          </a:effectRef>
+          <a:fontRef idx="minor">
+            <a:schemeClr val="lt1"/>
+          </a:fontRef>
+        </p:style>
+        <p:txBody>
+          <a:bodyPr rtlCol="0" anchor="ctr"/>
+          <a:lstStyle/>
+          <a:p>
+            <a:pPr algn="ctr"/>
+            <a:r>
+              <a:rPr lang="es-ES" dirty="0"/>
+              <a:t>Medical </a:t>
+            </a:r>
+            <a:r>
+              <a:rPr lang="es-ES" dirty="0" err="1"/>
+              <a:t>Consultation</a:t>
+            </a:r>
+            <a:r>
+              <a:rPr lang="es-ES" dirty="0"/>
+              <a:t> </a:t>
+            </a:r>
+          </a:p>
+          <a:p>
+            <a:pPr algn="ctr"/>
+            <a:r>
+              <a:rPr lang="es-ES" dirty="0"/>
+              <a:t>142 eventos</a:t>
+            </a:r>
+            <a:endParaRPr lang="en-GB" dirty="0"/>
+          </a:p>
+        </p:txBody>
+      </p:sp>
+      <p:sp>
+        <p:nvSpPr>
+          <p:cNvPr id="15" name="Hexagon 14">
+            <a:extLst>
+              <a:ext uri="{FF2B5EF4-FFF2-40B4-BE49-F238E27FC236}">
+                <a16:creationId xmlns:a16="http://schemas.microsoft.com/office/drawing/2014/main" id="{135604CC-F702-6577-CEC7-9CC52B942FAD}"/>
+              </a:ext>
+            </a:extLst>
+          </p:cNvPr>
+          <p:cNvSpPr/>
+          <p:nvPr/>
+        </p:nvSpPr>
+        <p:spPr>
+          <a:xfrm>
+            <a:off x="7464068" y="4953955"/>
+            <a:ext cx="1280410" cy="1083039"/>
+          </a:xfrm>
+          <a:prstGeom prst="hexagon">
+            <a:avLst/>
+          </a:prstGeom>
+        </p:spPr>
+        <p:style>
+          <a:lnRef idx="2">
+            <a:schemeClr val="accent1">
+              <a:shade val="15000"/>
+            </a:schemeClr>
+          </a:lnRef>
+          <a:fillRef idx="1">
+            <a:schemeClr val="accent1"/>
+          </a:fillRef>
+          <a:effectRef idx="0">
+            <a:schemeClr val="accent1"/>
+          </a:effectRef>
+          <a:fontRef idx="minor">
+            <a:schemeClr val="lt1"/>
+          </a:fontRef>
+        </p:style>
+        <p:txBody>
+          <a:bodyPr rtlCol="0" anchor="ctr"/>
+          <a:lstStyle/>
+          <a:p>
+            <a:pPr algn="ctr"/>
+            <a:r>
+              <a:rPr lang="es-ES" dirty="0"/>
+              <a:t>0.35</a:t>
+            </a:r>
+            <a:endParaRPr lang="en-GB" dirty="0"/>
           </a:p>
         </p:txBody>
       </p:sp>
@@ -9597,7 +10688,7 @@
         </p:spPr>
         <p:txBody>
           <a:bodyPr anchor="t" anchorCtr="0">
-            <a:normAutofit/>
+            <a:normAutofit fontScale="92500" lnSpcReduction="10000"/>
           </a:bodyPr>
           <a:lstStyle/>
           <a:p>
@@ -9702,6 +10793,12 @@
             <a:r>
               <a:rPr lang="en-US" dirty="0"/>
               <a:t> </a:t>
+            </a:r>
+          </a:p>
+          <a:p>
+            <a:r>
+              <a:rPr lang="en-US" dirty="0"/>
+              <a:t>KPIs</a:t>
             </a:r>
           </a:p>
         </p:txBody>
@@ -9865,10 +10962,6 @@
           <a:bodyPr/>
           <a:lstStyle/>
           <a:p>
-            <a:r>
-              <a:rPr lang="en-US" dirty="0" err="1"/>
-              <a:t>xxxxxxx</a:t>
-            </a:r>
             <a:endParaRPr lang="en-US" dirty="0"/>
           </a:p>
         </p:txBody>
@@ -10461,10 +11554,6 @@
           <a:bodyPr/>
           <a:lstStyle/>
           <a:p>
-            <a:r>
-              <a:rPr lang="en-US" dirty="0" err="1"/>
-              <a:t>xxxxxxxx</a:t>
-            </a:r>
             <a:endParaRPr lang="en-US" dirty="0"/>
           </a:p>
         </p:txBody>
@@ -11338,31 +12427,68 @@
           </a:p>
         </p:txBody>
       </p:sp>
-      <p:sp>
-        <p:nvSpPr>
-          <p:cNvPr id="5" name="Content Placeholder 4">
-            <a:extLst>
-              <a:ext uri="{FF2B5EF4-FFF2-40B4-BE49-F238E27FC236}">
-                <a16:creationId xmlns:a16="http://schemas.microsoft.com/office/drawing/2014/main" id="{60980DF7-A09D-57C4-737A-0D3BF8348406}"/>
-              </a:ext>
-            </a:extLst>
-          </p:cNvPr>
-          <p:cNvSpPr>
-            <a:spLocks noGrp="1"/>
-          </p:cNvSpPr>
+      <p:pic>
+        <p:nvPicPr>
+          <p:cNvPr id="7" name="Content Placeholder 6">
+            <a:extLst>
+              <a:ext uri="{FF2B5EF4-FFF2-40B4-BE49-F238E27FC236}">
+                <a16:creationId xmlns:a16="http://schemas.microsoft.com/office/drawing/2014/main" id="{E343A460-0061-9980-BD58-1B802E49313E}"/>
+              </a:ext>
+            </a:extLst>
+          </p:cNvPr>
+          <p:cNvPicPr>
+            <a:picLocks noGrp="1" noChangeAspect="1"/>
+          </p:cNvPicPr>
           <p:nvPr>
             <p:ph idx="30"/>
           </p:nvPr>
-        </p:nvSpPr>
-        <p:spPr/>
-        <p:txBody>
-          <a:bodyPr/>
-          <a:lstStyle/>
-          <a:p>
-            <a:endParaRPr lang="en-GB" dirty="0"/>
-          </a:p>
-        </p:txBody>
-      </p:sp>
+        </p:nvPicPr>
+        <p:blipFill>
+          <a:blip r:embed="rId3"/>
+          <a:stretch>
+            <a:fillRect/>
+          </a:stretch>
+        </p:blipFill>
+        <p:spPr>
+          <a:xfrm>
+            <a:off x="333652" y="2053653"/>
+            <a:ext cx="5336668" cy="3373438"/>
+          </a:xfrm>
+          <a:prstGeom prst="rect">
+            <a:avLst/>
+          </a:prstGeom>
+        </p:spPr>
+      </p:pic>
+      <p:pic>
+        <p:nvPicPr>
+          <p:cNvPr id="5" name="Picture 4">
+            <a:extLst>
+              <a:ext uri="{FF2B5EF4-FFF2-40B4-BE49-F238E27FC236}">
+                <a16:creationId xmlns:a16="http://schemas.microsoft.com/office/drawing/2014/main" id="{4FE71423-B06A-2A95-FE4C-ECAF5CB44988}"/>
+              </a:ext>
+            </a:extLst>
+          </p:cNvPr>
+          <p:cNvPicPr>
+            <a:picLocks noChangeAspect="1"/>
+          </p:cNvPicPr>
+          <p:nvPr/>
+        </p:nvPicPr>
+        <p:blipFill>
+          <a:blip r:embed="rId4"/>
+          <a:stretch>
+            <a:fillRect/>
+          </a:stretch>
+        </p:blipFill>
+        <p:spPr>
+          <a:xfrm>
+            <a:off x="6091550" y="1834548"/>
+            <a:ext cx="5038100" cy="3592543"/>
+          </a:xfrm>
+          <a:prstGeom prst="rect">
+            <a:avLst/>
+          </a:prstGeom>
+        </p:spPr>
+      </p:pic>
     </p:spTree>
     <p:extLst>
       <p:ext uri="{BB962C8B-B14F-4D97-AF65-F5344CB8AC3E}">
@@ -11651,31 +12777,98 @@
           </a:p>
         </p:txBody>
       </p:sp>
-      <p:sp>
-        <p:nvSpPr>
-          <p:cNvPr id="5" name="Content Placeholder 4">
-            <a:extLst>
-              <a:ext uri="{FF2B5EF4-FFF2-40B4-BE49-F238E27FC236}">
-                <a16:creationId xmlns:a16="http://schemas.microsoft.com/office/drawing/2014/main" id="{60980DF7-A09D-57C4-737A-0D3BF8348406}"/>
-              </a:ext>
-            </a:extLst>
-          </p:cNvPr>
-          <p:cNvSpPr>
-            <a:spLocks noGrp="1"/>
-          </p:cNvSpPr>
+      <p:pic>
+        <p:nvPicPr>
+          <p:cNvPr id="7" name="Content Placeholder 6">
+            <a:extLst>
+              <a:ext uri="{FF2B5EF4-FFF2-40B4-BE49-F238E27FC236}">
+                <a16:creationId xmlns:a16="http://schemas.microsoft.com/office/drawing/2014/main" id="{4CA7B066-56F3-903C-55CF-5E4907F2B09E}"/>
+              </a:ext>
+            </a:extLst>
+          </p:cNvPr>
+          <p:cNvPicPr>
+            <a:picLocks noGrp="1" noChangeAspect="1"/>
+          </p:cNvPicPr>
           <p:nvPr>
             <p:ph idx="30"/>
           </p:nvPr>
-        </p:nvSpPr>
-        <p:spPr/>
-        <p:txBody>
-          <a:bodyPr/>
-          <a:lstStyle/>
-          <a:p>
-            <a:endParaRPr lang="en-GB" dirty="0"/>
-          </a:p>
-        </p:txBody>
-      </p:sp>
+        </p:nvPicPr>
+        <p:blipFill>
+          <a:blip r:embed="rId3"/>
+          <a:stretch>
+            <a:fillRect/>
+          </a:stretch>
+        </p:blipFill>
+        <p:spPr>
+          <a:xfrm>
+            <a:off x="528612" y="1708879"/>
+            <a:ext cx="4507604" cy="2492440"/>
+          </a:xfrm>
+          <a:prstGeom prst="rect">
+            <a:avLst/>
+          </a:prstGeom>
+        </p:spPr>
+      </p:pic>
+      <p:pic>
+        <p:nvPicPr>
+          <p:cNvPr id="9" name="Picture 8">
+            <a:extLst>
+              <a:ext uri="{FF2B5EF4-FFF2-40B4-BE49-F238E27FC236}">
+                <a16:creationId xmlns:a16="http://schemas.microsoft.com/office/drawing/2014/main" id="{939BC8FE-223B-9DD7-262A-A777F126EA64}"/>
+              </a:ext>
+            </a:extLst>
+          </p:cNvPr>
+          <p:cNvPicPr>
+            <a:picLocks noChangeAspect="1"/>
+          </p:cNvPicPr>
+          <p:nvPr/>
+        </p:nvPicPr>
+        <p:blipFill>
+          <a:blip r:embed="rId4"/>
+          <a:stretch>
+            <a:fillRect/>
+          </a:stretch>
+        </p:blipFill>
+        <p:spPr>
+          <a:xfrm>
+            <a:off x="3746382" y="4153915"/>
+            <a:ext cx="4041775" cy="2704085"/>
+          </a:xfrm>
+          <a:prstGeom prst="rect">
+            <a:avLst/>
+          </a:prstGeom>
+        </p:spPr>
+      </p:pic>
+      <p:pic>
+        <p:nvPicPr>
+          <p:cNvPr id="11" name="Picture 10">
+            <a:extLst>
+              <a:ext uri="{FF2B5EF4-FFF2-40B4-BE49-F238E27FC236}">
+                <a16:creationId xmlns:a16="http://schemas.microsoft.com/office/drawing/2014/main" id="{E0CAEE3F-AF86-05B7-D1DC-1E272BD82B3E}"/>
+              </a:ext>
+            </a:extLst>
+          </p:cNvPr>
+          <p:cNvPicPr>
+            <a:picLocks noChangeAspect="1"/>
+          </p:cNvPicPr>
+          <p:nvPr/>
+        </p:nvPicPr>
+        <p:blipFill>
+          <a:blip r:embed="rId5"/>
+          <a:stretch>
+            <a:fillRect/>
+          </a:stretch>
+        </p:blipFill>
+        <p:spPr>
+          <a:xfrm>
+            <a:off x="6424731" y="1805261"/>
+            <a:ext cx="5112606" cy="2396058"/>
+          </a:xfrm>
+          <a:prstGeom prst="rect">
+            <a:avLst/>
+          </a:prstGeom>
+        </p:spPr>
+      </p:pic>
     </p:spTree>
     <p:extLst>
       <p:ext uri="{BB962C8B-B14F-4D97-AF65-F5344CB8AC3E}">

</xml_diff>

<commit_message>
Corrección breve de la diapositiva 6
</commit_message>
<xml_diff>
--- a/Equip_28/Results/Analisis_PAP_and_ABL_RapidExpres.pptx
+++ b/Equip_28/Results/Analisis_PAP_and_ABL_RapidExpres.pptx
@@ -209,7 +209,7 @@
           <a:p>
             <a:fld id="{443A06E2-0DF3-432C-9669-7DF986ACE8BA}" type="datetimeFigureOut">
               <a:rPr lang="en-GB" smtClean="0"/>
-              <a:t>24/04/2026</a:t>
+              <a:t>27/04/2026</a:t>
             </a:fld>
             <a:endParaRPr lang="en-GB"/>
           </a:p>
@@ -368,7 +368,7 @@
           <a:p>
             <a:fld id="{005AAB3B-1C4E-4889-8450-736287798921}" type="slidenum">
               <a:rPr lang="en-GB" smtClean="0"/>
-              <a:t>‹#›</a:t>
+              <a:t>‹Nº›</a:t>
             </a:fld>
             <a:endParaRPr lang="en-GB"/>
           </a:p>
@@ -1502,7 +1502,7 @@
           <a:p>
             <a:fld id="{037D434A-83FD-40C7-B814-5B722EE835FE}" type="datetimeFigureOut">
               <a:rPr lang="en-GB" smtClean="0"/>
-              <a:t>24/04/2026</a:t>
+              <a:t>27/04/2026</a:t>
             </a:fld>
             <a:endParaRPr lang="en-GB"/>
           </a:p>
@@ -1556,7 +1556,7 @@
           <a:p>
             <a:fld id="{BE6A8D57-9D10-4D47-9091-49E61AADFCFC}" type="slidenum">
               <a:rPr lang="en-GB" smtClean="0"/>
-              <a:t>‹#›</a:t>
+              <a:t>‹Nº›</a:t>
             </a:fld>
             <a:endParaRPr lang="en-GB"/>
           </a:p>
@@ -1702,7 +1702,7 @@
           <a:p>
             <a:fld id="{037D434A-83FD-40C7-B814-5B722EE835FE}" type="datetimeFigureOut">
               <a:rPr lang="en-GB" smtClean="0"/>
-              <a:t>24/04/2026</a:t>
+              <a:t>27/04/2026</a:t>
             </a:fld>
             <a:endParaRPr lang="en-GB"/>
           </a:p>
@@ -1756,7 +1756,7 @@
           <a:p>
             <a:fld id="{BE6A8D57-9D10-4D47-9091-49E61AADFCFC}" type="slidenum">
               <a:rPr lang="en-GB" smtClean="0"/>
-              <a:t>‹#›</a:t>
+              <a:t>‹Nº›</a:t>
             </a:fld>
             <a:endParaRPr lang="en-GB"/>
           </a:p>
@@ -1912,7 +1912,7 @@
           <a:p>
             <a:fld id="{037D434A-83FD-40C7-B814-5B722EE835FE}" type="datetimeFigureOut">
               <a:rPr lang="en-GB" smtClean="0"/>
-              <a:t>24/04/2026</a:t>
+              <a:t>27/04/2026</a:t>
             </a:fld>
             <a:endParaRPr lang="en-GB"/>
           </a:p>
@@ -1966,7 +1966,7 @@
           <a:p>
             <a:fld id="{BE6A8D57-9D10-4D47-9091-49E61AADFCFC}" type="slidenum">
               <a:rPr lang="en-GB" smtClean="0"/>
-              <a:t>‹#›</a:t>
+              <a:t>‹Nº›</a:t>
             </a:fld>
             <a:endParaRPr lang="en-GB"/>
           </a:p>
@@ -3910,7 +3910,7 @@
             <a:fld id="{47FEACEE-25B4-4A2D-B147-27296E36371D}" type="slidenum">
               <a:rPr lang="en-US" altLang="zh-CN" noProof="0" smtClean="0"/>
               <a:pPr/>
-              <a:t>‹#›</a:t>
+              <a:t>‹Nº›</a:t>
             </a:fld>
             <a:endParaRPr lang="en-US" altLang="zh-CN" noProof="0" dirty="0"/>
           </a:p>
@@ -5798,7 +5798,7 @@
             <a:fld id="{47FEACEE-25B4-4A2D-B147-27296E36371D}" type="slidenum">
               <a:rPr lang="en-US" altLang="zh-CN" noProof="0" smtClean="0"/>
               <a:pPr/>
-              <a:t>‹#›</a:t>
+              <a:t>‹Nº›</a:t>
             </a:fld>
             <a:endParaRPr lang="en-US" altLang="zh-CN" noProof="0" dirty="0"/>
           </a:p>
@@ -5944,7 +5944,7 @@
           <a:p>
             <a:fld id="{037D434A-83FD-40C7-B814-5B722EE835FE}" type="datetimeFigureOut">
               <a:rPr lang="en-GB" smtClean="0"/>
-              <a:t>24/04/2026</a:t>
+              <a:t>27/04/2026</a:t>
             </a:fld>
             <a:endParaRPr lang="en-GB"/>
           </a:p>
@@ -5998,7 +5998,7 @@
           <a:p>
             <a:fld id="{BE6A8D57-9D10-4D47-9091-49E61AADFCFC}" type="slidenum">
               <a:rPr lang="en-GB" smtClean="0"/>
-              <a:t>‹#›</a:t>
+              <a:t>‹Nº›</a:t>
             </a:fld>
             <a:endParaRPr lang="en-GB"/>
           </a:p>
@@ -6220,7 +6220,7 @@
           <a:p>
             <a:fld id="{037D434A-83FD-40C7-B814-5B722EE835FE}" type="datetimeFigureOut">
               <a:rPr lang="en-GB" smtClean="0"/>
-              <a:t>24/04/2026</a:t>
+              <a:t>27/04/2026</a:t>
             </a:fld>
             <a:endParaRPr lang="en-GB"/>
           </a:p>
@@ -6274,7 +6274,7 @@
           <a:p>
             <a:fld id="{BE6A8D57-9D10-4D47-9091-49E61AADFCFC}" type="slidenum">
               <a:rPr lang="en-GB" smtClean="0"/>
-              <a:t>‹#›</a:t>
+              <a:t>‹Nº›</a:t>
             </a:fld>
             <a:endParaRPr lang="en-GB"/>
           </a:p>
@@ -6488,7 +6488,7 @@
           <a:p>
             <a:fld id="{037D434A-83FD-40C7-B814-5B722EE835FE}" type="datetimeFigureOut">
               <a:rPr lang="en-GB" smtClean="0"/>
-              <a:t>24/04/2026</a:t>
+              <a:t>27/04/2026</a:t>
             </a:fld>
             <a:endParaRPr lang="en-GB"/>
           </a:p>
@@ -6542,7 +6542,7 @@
           <a:p>
             <a:fld id="{BE6A8D57-9D10-4D47-9091-49E61AADFCFC}" type="slidenum">
               <a:rPr lang="en-GB" smtClean="0"/>
-              <a:t>‹#›</a:t>
+              <a:t>‹Nº›</a:t>
             </a:fld>
             <a:endParaRPr lang="en-GB"/>
           </a:p>
@@ -6903,7 +6903,7 @@
           <a:p>
             <a:fld id="{037D434A-83FD-40C7-B814-5B722EE835FE}" type="datetimeFigureOut">
               <a:rPr lang="en-GB" smtClean="0"/>
-              <a:t>24/04/2026</a:t>
+              <a:t>27/04/2026</a:t>
             </a:fld>
             <a:endParaRPr lang="en-GB"/>
           </a:p>
@@ -6957,7 +6957,7 @@
           <a:p>
             <a:fld id="{BE6A8D57-9D10-4D47-9091-49E61AADFCFC}" type="slidenum">
               <a:rPr lang="en-GB" smtClean="0"/>
-              <a:t>‹#›</a:t>
+              <a:t>‹Nº›</a:t>
             </a:fld>
             <a:endParaRPr lang="en-GB"/>
           </a:p>
@@ -7045,7 +7045,7 @@
           <a:p>
             <a:fld id="{037D434A-83FD-40C7-B814-5B722EE835FE}" type="datetimeFigureOut">
               <a:rPr lang="en-GB" smtClean="0"/>
-              <a:t>24/04/2026</a:t>
+              <a:t>27/04/2026</a:t>
             </a:fld>
             <a:endParaRPr lang="en-GB"/>
           </a:p>
@@ -7099,7 +7099,7 @@
           <a:p>
             <a:fld id="{BE6A8D57-9D10-4D47-9091-49E61AADFCFC}" type="slidenum">
               <a:rPr lang="en-GB" smtClean="0"/>
-              <a:t>‹#›</a:t>
+              <a:t>‹Nº›</a:t>
             </a:fld>
             <a:endParaRPr lang="en-GB"/>
           </a:p>
@@ -7158,7 +7158,7 @@
           <a:p>
             <a:fld id="{037D434A-83FD-40C7-B814-5B722EE835FE}" type="datetimeFigureOut">
               <a:rPr lang="en-GB" smtClean="0"/>
-              <a:t>24/04/2026</a:t>
+              <a:t>27/04/2026</a:t>
             </a:fld>
             <a:endParaRPr lang="en-GB"/>
           </a:p>
@@ -7212,7 +7212,7 @@
           <a:p>
             <a:fld id="{BE6A8D57-9D10-4D47-9091-49E61AADFCFC}" type="slidenum">
               <a:rPr lang="en-GB" smtClean="0"/>
-              <a:t>‹#›</a:t>
+              <a:t>‹Nº›</a:t>
             </a:fld>
             <a:endParaRPr lang="en-GB"/>
           </a:p>
@@ -7471,7 +7471,7 @@
           <a:p>
             <a:fld id="{037D434A-83FD-40C7-B814-5B722EE835FE}" type="datetimeFigureOut">
               <a:rPr lang="en-GB" smtClean="0"/>
-              <a:t>24/04/2026</a:t>
+              <a:t>27/04/2026</a:t>
             </a:fld>
             <a:endParaRPr lang="en-GB"/>
           </a:p>
@@ -7525,7 +7525,7 @@
           <a:p>
             <a:fld id="{BE6A8D57-9D10-4D47-9091-49E61AADFCFC}" type="slidenum">
               <a:rPr lang="en-GB" smtClean="0"/>
-              <a:t>‹#›</a:t>
+              <a:t>‹Nº›</a:t>
             </a:fld>
             <a:endParaRPr lang="en-GB"/>
           </a:p>
@@ -7760,7 +7760,7 @@
           <a:p>
             <a:fld id="{037D434A-83FD-40C7-B814-5B722EE835FE}" type="datetimeFigureOut">
               <a:rPr lang="en-GB" smtClean="0"/>
-              <a:t>24/04/2026</a:t>
+              <a:t>27/04/2026</a:t>
             </a:fld>
             <a:endParaRPr lang="en-GB"/>
           </a:p>
@@ -7814,7 +7814,7 @@
           <a:p>
             <a:fld id="{BE6A8D57-9D10-4D47-9091-49E61AADFCFC}" type="slidenum">
               <a:rPr lang="en-GB" smtClean="0"/>
-              <a:t>‹#›</a:t>
+              <a:t>‹Nº›</a:t>
             </a:fld>
             <a:endParaRPr lang="en-GB"/>
           </a:p>
@@ -8003,7 +8003,7 @@
           <a:p>
             <a:fld id="{037D434A-83FD-40C7-B814-5B722EE835FE}" type="datetimeFigureOut">
               <a:rPr lang="en-GB" smtClean="0"/>
-              <a:t>24/04/2026</a:t>
+              <a:t>27/04/2026</a:t>
             </a:fld>
             <a:endParaRPr lang="en-GB"/>
           </a:p>
@@ -8093,7 +8093,7 @@
           <a:p>
             <a:fld id="{BE6A8D57-9D10-4D47-9091-49E61AADFCFC}" type="slidenum">
               <a:rPr lang="en-GB" smtClean="0"/>
-              <a:t>‹#›</a:t>
+              <a:t>‹Nº›</a:t>
             </a:fld>
             <a:endParaRPr lang="en-GB"/>
           </a:p>
@@ -8459,65 +8459,28 @@
           <a:lstStyle/>
           <a:p>
             <a:r>
-              <a:rPr lang="en-US" altLang="zh-CN" dirty="0">
+              <a:rPr lang="es-ES_tradnl" noProof="1">
                 <a:solidFill>
                   <a:schemeClr val="bg1"/>
                 </a:solidFill>
               </a:rPr>
-              <a:t>Rapid Express – </a:t>
-            </a:r>
-            <a:r>
-              <a:rPr lang="en-US" altLang="zh-CN" dirty="0" err="1">
-                <a:solidFill>
-                  <a:schemeClr val="bg1"/>
-                </a:solidFill>
-              </a:rPr>
-              <a:t>Analisis</a:t>
-            </a:r>
-            <a:r>
-              <a:rPr lang="en-US" altLang="zh-CN" dirty="0">
-                <a:solidFill>
-                  <a:schemeClr val="bg1"/>
-                </a:solidFill>
-              </a:rPr>
-              <a:t> </a:t>
+              <a:t>Rapid Express – Análisis </a:t>
             </a:r>
             <a:br>
-              <a:rPr lang="en-US" altLang="zh-CN" dirty="0">
+              <a:rPr lang="es-ES_tradnl" noProof="1">
                 <a:solidFill>
                   <a:schemeClr val="bg1"/>
                 </a:solidFill>
               </a:rPr>
             </a:br>
             <a:r>
-              <a:rPr lang="en-US" altLang="zh-CN" dirty="0" err="1">
+              <a:rPr lang="es-ES_tradnl" noProof="1">
                 <a:solidFill>
                   <a:schemeClr val="bg1"/>
                 </a:solidFill>
               </a:rPr>
-              <a:t>Perfil</a:t>
-            </a:r>
-            <a:r>
-              <a:rPr lang="en-US" altLang="zh-CN" dirty="0">
-                <a:solidFill>
-                  <a:schemeClr val="bg1"/>
-                </a:solidFill>
-              </a:rPr>
-              <a:t> de Empleado y </a:t>
-            </a:r>
-            <a:r>
-              <a:rPr lang="en-US" altLang="zh-CN" dirty="0" err="1">
-                <a:solidFill>
-                  <a:schemeClr val="bg1"/>
-                </a:solidFill>
-              </a:rPr>
-              <a:t>Absentismo</a:t>
-            </a:r>
-            <a:endParaRPr lang="en-US" dirty="0">
-              <a:solidFill>
-                <a:schemeClr val="bg1"/>
-              </a:solidFill>
-            </a:endParaRPr>
+              <a:t>Perfil de Empleado y Absentismo</a:t>
+            </a:r>
           </a:p>
         </p:txBody>
       </p:sp>
@@ -8548,17 +8511,13 @@
           <a:lstStyle/>
           <a:p>
             <a:r>
-              <a:rPr lang="en-US" dirty="0" err="1"/>
-              <a:t>Equipo</a:t>
-            </a:r>
-            <a:r>
-              <a:rPr lang="en-US" dirty="0"/>
-              <a:t> 28</a:t>
-            </a:r>
-          </a:p>
-          <a:p>
-            <a:r>
-              <a:rPr lang="en-US" dirty="0"/>
+              <a:rPr lang="es-ES_tradnl" noProof="1"/>
+              <a:t>Equipo 28</a:t>
+            </a:r>
+          </a:p>
+          <a:p>
+            <a:r>
+              <a:rPr lang="es-ES_tradnl" noProof="1"/>
               <a:t>Emilio T., Núria P., Andrea C. &amp; Ana C.</a:t>
             </a:r>
           </a:p>
@@ -8663,65 +8622,17 @@
           <a:lstStyle/>
           <a:p>
             <a:r>
-              <a:rPr lang="en-US" dirty="0" err="1">
+              <a:rPr lang="es-ES_tradnl" noProof="1">
                 <a:solidFill>
                   <a:schemeClr val="bg1"/>
                 </a:solidFill>
               </a:rPr>
-              <a:t>Estrategias</a:t>
-            </a:r>
-            <a:r>
-              <a:rPr lang="en-US" dirty="0">
-                <a:solidFill>
-                  <a:schemeClr val="bg1"/>
-                </a:solidFill>
-              </a:rPr>
-              <a:t> para </a:t>
-            </a:r>
-            <a:r>
-              <a:rPr lang="en-US" dirty="0" err="1">
-                <a:solidFill>
-                  <a:schemeClr val="bg1"/>
-                </a:solidFill>
-              </a:rPr>
-              <a:t>reducir</a:t>
-            </a:r>
-            <a:r>
-              <a:rPr lang="en-US" dirty="0">
-                <a:solidFill>
-                  <a:schemeClr val="bg1"/>
-                </a:solidFill>
-              </a:rPr>
-              <a:t> </a:t>
-            </a:r>
-            <a:r>
-              <a:rPr lang="en-US" dirty="0" err="1">
-                <a:solidFill>
-                  <a:schemeClr val="bg1"/>
-                </a:solidFill>
-              </a:rPr>
-              <a:t>el</a:t>
-            </a:r>
-            <a:r>
-              <a:rPr lang="en-US" dirty="0">
-                <a:solidFill>
-                  <a:schemeClr val="bg1"/>
-                </a:solidFill>
-              </a:rPr>
-              <a:t> </a:t>
-            </a:r>
-            <a:r>
-              <a:rPr lang="en-US" dirty="0" err="1">
-                <a:solidFill>
-                  <a:schemeClr val="bg1"/>
-                </a:solidFill>
-              </a:rPr>
-              <a:t>ausentismo</a:t>
+              <a:t>Estrategias para reducir el ausentismo</a:t>
             </a:r>
             <a:br>
-              <a:rPr lang="en-US" dirty="0"/>
+              <a:rPr lang="es-ES_tradnl" noProof="1"/>
             </a:br>
-            <a:endParaRPr lang="en-US" dirty="0">
+            <a:endParaRPr lang="es-ES_tradnl" noProof="1">
               <a:solidFill>
                 <a:schemeClr val="bg1"/>
               </a:solidFill>
@@ -8755,7 +8666,7 @@
           <a:bodyPr/>
           <a:lstStyle/>
           <a:p>
-            <a:endParaRPr lang="en-US" dirty="0"/>
+            <a:endParaRPr lang="es-ES_tradnl" noProof="1"/>
           </a:p>
         </p:txBody>
       </p:sp>
@@ -8824,7 +8735,7 @@
           <a:lstStyle/>
           <a:p>
             <a:r>
-              <a:rPr lang="es-ES" dirty="0"/>
+              <a:rPr lang="es-ES_tradnl" noProof="1"/>
               <a:t>Estrategias para reducir el Ausentismo</a:t>
             </a:r>
           </a:p>
@@ -8969,7 +8880,7 @@
               <a:defRPr/>
             </a:pPr>
             <a:fld id="{47FEACEE-25B4-4A2D-B147-27296E36371D}" type="slidenum">
-              <a:rPr kumimoji="0" lang="en-US" altLang="zh-CN" sz="1200" u="none" strike="noStrike" kern="1200" cap="none" spc="0" normalizeH="0" baseline="0" smtClean="0">
+              <a:rPr kumimoji="0" lang="es-ES_tradnl" sz="1200" u="none" strike="noStrike" kern="1200" cap="none" spc="0" normalizeH="0" baseline="0" noProof="1" smtClean="0">
                 <a:ln>
                   <a:noFill/>
                 </a:ln>
@@ -8999,7 +8910,7 @@
               </a:pPr>
               <a:t>11</a:t>
             </a:fld>
-            <a:endParaRPr kumimoji="0" lang="en-US" altLang="zh-CN" sz="1200" u="none" strike="noStrike" kern="1200" cap="none" spc="0" normalizeH="0" baseline="0" dirty="0">
+            <a:endParaRPr kumimoji="0" lang="es-ES_tradnl" sz="1200" u="none" strike="noStrike" kern="1200" cap="none" spc="0" normalizeH="0" baseline="0" noProof="1">
               <a:ln>
                 <a:noFill/>
               </a:ln>
@@ -9035,11 +8946,11 @@
           <a:lstStyle/>
           <a:p>
             <a:fld id="{47FEACEE-25B4-4A2D-B147-27296E36371D}" type="slidenum">
-              <a:rPr lang="en-US" altLang="zh-CN" noProof="0" smtClean="0"/>
+              <a:rPr lang="es-ES_tradnl" noProof="1" smtClean="0"/>
               <a:pPr/>
               <a:t>11</a:t>
             </a:fld>
-            <a:endParaRPr lang="en-US" altLang="zh-CN" noProof="0" dirty="0"/>
+            <a:endParaRPr lang="es-ES_tradnl" noProof="1"/>
           </a:p>
         </p:txBody>
       </p:sp>
@@ -9073,19 +8984,19 @@
               <a:buNone/>
             </a:pPr>
             <a:r>
-              <a:rPr lang="es-ES" dirty="0"/>
+              <a:rPr lang="es-ES_tradnl" noProof="1"/>
               <a:t>. </a:t>
             </a:r>
             <a:r>
-              <a:rPr lang="es-ES" b="1" dirty="0"/>
+              <a:rPr lang="es-ES_tradnl" b="1" noProof="1"/>
               <a:t>Invierno</a:t>
             </a:r>
             <a:r>
-              <a:rPr lang="es-ES" dirty="0"/>
+              <a:rPr lang="es-ES_tradnl" noProof="1"/>
               <a:t> - Campañas de salud, ergonomía, prevención de lesiones, vacunación</a:t>
             </a:r>
             <a:r>
-              <a:rPr lang="es-ES" b="1" dirty="0"/>
+              <a:rPr lang="es-ES_tradnl" b="1" noProof="1"/>
               <a:t>.</a:t>
             </a:r>
           </a:p>
@@ -9093,174 +9004,46 @@
             <a:pPr marL="457200" lvl="1" indent="0">
               <a:buNone/>
             </a:pPr>
-            <a:endParaRPr lang="en-GB" dirty="0"/>
+            <a:endParaRPr lang="es-ES_tradnl" noProof="1"/>
           </a:p>
           <a:p>
             <a:pPr marL="457200" lvl="1" indent="0">
               <a:buNone/>
             </a:pPr>
             <a:r>
-              <a:rPr lang="en-GB" dirty="0"/>
+              <a:rPr lang="es-ES_tradnl" noProof="1"/>
               <a:t>. </a:t>
             </a:r>
             <a:r>
-              <a:rPr lang="en-GB" b="1" dirty="0"/>
-              <a:t>Meses </a:t>
-            </a:r>
-            <a:r>
-              <a:rPr lang="en-GB" b="1" dirty="0" err="1"/>
-              <a:t>pico</a:t>
-            </a:r>
-            <a:r>
-              <a:rPr lang="en-GB" b="1" dirty="0"/>
-              <a:t> (Marzo, Abril, Julio y </a:t>
-            </a:r>
-            <a:r>
-              <a:rPr lang="en-GB" b="1" dirty="0" err="1"/>
-              <a:t>Noviembre</a:t>
-            </a:r>
-            <a:r>
-              <a:rPr lang="en-GB" b="1" dirty="0"/>
-              <a:t>) </a:t>
-            </a:r>
-            <a:r>
-              <a:rPr lang="en-GB" dirty="0"/>
-              <a:t>- </a:t>
-            </a:r>
-            <a:r>
-              <a:rPr lang="en-GB" dirty="0" err="1"/>
-              <a:t>Redimensionar</a:t>
-            </a:r>
-            <a:r>
-              <a:rPr lang="en-GB" dirty="0"/>
-              <a:t> </a:t>
-            </a:r>
-            <a:r>
-              <a:rPr lang="en-GB" dirty="0" err="1"/>
-              <a:t>período</a:t>
-            </a:r>
-            <a:r>
-              <a:rPr lang="en-GB" dirty="0"/>
-              <a:t> </a:t>
-            </a:r>
-            <a:r>
-              <a:rPr lang="en-GB" dirty="0" err="1"/>
-              <a:t>vacacional</a:t>
-            </a:r>
-            <a:r>
-              <a:rPr lang="en-GB" dirty="0"/>
-              <a:t> </a:t>
-            </a:r>
-            <a:r>
-              <a:rPr lang="en-GB" dirty="0" err="1"/>
-              <a:t>acorde</a:t>
-            </a:r>
-            <a:r>
-              <a:rPr lang="en-GB" dirty="0"/>
-              <a:t> con </a:t>
-            </a:r>
-            <a:r>
-              <a:rPr lang="en-GB" dirty="0" err="1"/>
-              <a:t>los</a:t>
-            </a:r>
-            <a:r>
-              <a:rPr lang="en-GB" dirty="0"/>
-              <a:t> meses </a:t>
-            </a:r>
-            <a:r>
-              <a:rPr lang="en-GB" dirty="0" err="1"/>
-              <a:t>pico</a:t>
-            </a:r>
-            <a:r>
-              <a:rPr lang="en-GB" dirty="0"/>
-              <a:t> de </a:t>
-            </a:r>
-            <a:r>
-              <a:rPr lang="en-GB" dirty="0" err="1"/>
-              <a:t>ausentísmo</a:t>
-            </a:r>
-            <a:r>
-              <a:rPr lang="en-GB" dirty="0"/>
-              <a:t> (Marzo, Abril, Julio y Noviembe</a:t>
+              <a:rPr lang="es-ES_tradnl" b="1" noProof="1"/>
+              <a:t>Meses pico (Marzo, Abril, Julio y Noviembre) </a:t>
+            </a:r>
+            <a:r>
+              <a:rPr lang="es-ES_tradnl" noProof="1"/>
+              <a:t>- Redimensionar período vacacional acorde con los meses pico de ausentísmo (Marzo, Abril, Julio y Noviembe</a:t>
             </a:r>
           </a:p>
           <a:p>
             <a:pPr marL="457200" lvl="1" indent="0">
               <a:buNone/>
             </a:pPr>
-            <a:endParaRPr lang="en-GB" dirty="0"/>
+            <a:endParaRPr lang="es-ES_tradnl" noProof="1"/>
           </a:p>
           <a:p>
             <a:pPr marL="457200" lvl="1" indent="0">
               <a:buNone/>
             </a:pPr>
             <a:r>
-              <a:rPr lang="en-GB" dirty="0"/>
+              <a:rPr lang="es-ES_tradnl" noProof="1"/>
               <a:t>. </a:t>
             </a:r>
             <a:r>
-              <a:rPr lang="en-GB" b="1" dirty="0"/>
-              <a:t>Mayor </a:t>
-            </a:r>
-            <a:r>
-              <a:rPr lang="en-GB" b="1" dirty="0" err="1"/>
-              <a:t>acumulo</a:t>
-            </a:r>
-            <a:r>
-              <a:rPr lang="en-GB" b="1" dirty="0"/>
-              <a:t> de horas </a:t>
-            </a:r>
-            <a:r>
-              <a:rPr lang="en-GB" dirty="0"/>
-              <a:t>- </a:t>
-            </a:r>
-            <a:r>
-              <a:rPr lang="en-GB" dirty="0" err="1"/>
-              <a:t>Coordinación</a:t>
-            </a:r>
-            <a:r>
-              <a:rPr lang="en-GB" dirty="0"/>
-              <a:t> con </a:t>
-            </a:r>
-            <a:r>
-              <a:rPr lang="en-GB" dirty="0" err="1"/>
-              <a:t>servicios</a:t>
-            </a:r>
-            <a:r>
-              <a:rPr lang="en-GB" dirty="0"/>
-              <a:t> </a:t>
-            </a:r>
-            <a:r>
-              <a:rPr lang="en-GB" dirty="0" err="1"/>
-              <a:t>médicos</a:t>
-            </a:r>
-            <a:r>
-              <a:rPr lang="en-GB" dirty="0"/>
-              <a:t> para </a:t>
-            </a:r>
-            <a:r>
-              <a:rPr lang="en-GB" dirty="0" err="1"/>
-              <a:t>seguimiento</a:t>
-            </a:r>
-            <a:r>
-              <a:rPr lang="en-GB" dirty="0"/>
-              <a:t> </a:t>
-            </a:r>
-            <a:r>
-              <a:rPr lang="en-GB" dirty="0" err="1"/>
-              <a:t>temprano</a:t>
-            </a:r>
-            <a:r>
-              <a:rPr lang="en-GB" dirty="0"/>
-              <a:t> de </a:t>
-            </a:r>
-            <a:r>
-              <a:rPr lang="en-GB" dirty="0" err="1"/>
-              <a:t>casos</a:t>
-            </a:r>
-            <a:r>
-              <a:rPr lang="en-GB" dirty="0"/>
-              <a:t> &gt; 24h</a:t>
+              <a:rPr lang="es-ES_tradnl" b="1" noProof="1"/>
+              <a:t>Mayor acumulo de horas </a:t>
+            </a:r>
+            <a:r>
+              <a:rPr lang="es-ES_tradnl" noProof="1"/>
+              <a:t>- Coordinación con servicios médicos para seguimiento temprano de casos &gt; 24h</a:t>
             </a:r>
           </a:p>
         </p:txBody>
@@ -9336,7 +9119,7 @@
           <a:lstStyle/>
           <a:p>
             <a:r>
-              <a:rPr lang="en-US" dirty="0">
+              <a:rPr lang="es-ES_tradnl" noProof="1">
                 <a:solidFill>
                   <a:schemeClr val="bg1"/>
                 </a:solidFill>
@@ -9372,7 +9155,7 @@
           <a:bodyPr/>
           <a:lstStyle/>
           <a:p>
-            <a:endParaRPr lang="en-US" dirty="0"/>
+            <a:endParaRPr lang="es-ES_tradnl" noProof="1"/>
           </a:p>
         </p:txBody>
       </p:sp>
@@ -9439,7 +9222,7 @@
           <a:lstStyle/>
           <a:p>
             <a:r>
-              <a:rPr lang="en-US" dirty="0"/>
+              <a:rPr lang="es-ES_tradnl" noProof="1"/>
               <a:t>KPIs</a:t>
             </a:r>
           </a:p>
@@ -9477,37 +9260,24 @@
               <a:buNone/>
             </a:pPr>
             <a:r>
-              <a:rPr lang="en-US" b="1" dirty="0"/>
-              <a:t>% </a:t>
-            </a:r>
-            <a:r>
-              <a:rPr lang="en-US" b="1" dirty="0" err="1"/>
-              <a:t>Empleados</a:t>
-            </a:r>
-            <a:r>
-              <a:rPr lang="en-US" b="1" dirty="0"/>
-              <a:t> </a:t>
-            </a:r>
-            <a:r>
-              <a:rPr lang="en-US" b="1" dirty="0" err="1"/>
-              <a:t>ausentes</a:t>
-            </a:r>
-            <a:endParaRPr lang="en-US" b="1" dirty="0"/>
-          </a:p>
-          <a:p>
-            <a:endParaRPr lang="en-US" dirty="0"/>
-          </a:p>
-          <a:p>
-            <a:endParaRPr lang="en-US" dirty="0"/>
-          </a:p>
-          <a:p>
-            <a:endParaRPr lang="en-US" dirty="0"/>
+              <a:rPr lang="es-ES_tradnl" b="1" noProof="1"/>
+              <a:t>% Empleados ausentes</a:t>
+            </a:r>
+          </a:p>
+          <a:p>
+            <a:endParaRPr lang="es-ES_tradnl" noProof="1"/>
+          </a:p>
+          <a:p>
+            <a:endParaRPr lang="es-ES_tradnl" noProof="1"/>
+          </a:p>
+          <a:p>
+            <a:endParaRPr lang="es-ES_tradnl" noProof="1"/>
           </a:p>
           <a:p>
             <a:pPr marL="0" indent="0">
               <a:buNone/>
             </a:pPr>
-            <a:endParaRPr lang="en-US" dirty="0"/>
+            <a:endParaRPr lang="es-ES_tradnl" noProof="1"/>
           </a:p>
         </p:txBody>
       </p:sp>
@@ -9650,7 +9420,7 @@
               <a:defRPr/>
             </a:pPr>
             <a:fld id="{47FEACEE-25B4-4A2D-B147-27296E36371D}" type="slidenum">
-              <a:rPr kumimoji="0" lang="en-US" altLang="zh-CN" sz="1200" u="none" strike="noStrike" kern="1200" cap="none" spc="0" normalizeH="0" baseline="0" smtClean="0">
+              <a:rPr kumimoji="0" lang="es-ES_tradnl" sz="1200" u="none" strike="noStrike" kern="1200" cap="none" spc="0" normalizeH="0" baseline="0" noProof="1" smtClean="0">
                 <a:ln>
                   <a:noFill/>
                 </a:ln>
@@ -9680,7 +9450,7 @@
               </a:pPr>
               <a:t>13</a:t>
             </a:fld>
-            <a:endParaRPr kumimoji="0" lang="en-US" altLang="zh-CN" sz="1200" u="none" strike="noStrike" kern="1200" cap="none" spc="0" normalizeH="0" baseline="0" dirty="0">
+            <a:endParaRPr kumimoji="0" lang="es-ES_tradnl" sz="1200" u="none" strike="noStrike" kern="1200" cap="none" spc="0" normalizeH="0" baseline="0" noProof="1">
               <a:ln>
                 <a:noFill/>
               </a:ln>
@@ -9716,11 +9486,11 @@
           <a:lstStyle/>
           <a:p>
             <a:fld id="{47FEACEE-25B4-4A2D-B147-27296E36371D}" type="slidenum">
-              <a:rPr lang="en-US" altLang="zh-CN" noProof="0" smtClean="0"/>
+              <a:rPr lang="es-ES_tradnl" noProof="1" smtClean="0"/>
               <a:pPr/>
               <a:t>13</a:t>
             </a:fld>
-            <a:endParaRPr lang="en-US" altLang="zh-CN" noProof="0" dirty="0"/>
+            <a:endParaRPr lang="es-ES_tradnl" noProof="1"/>
           </a:p>
         </p:txBody>
       </p:sp>
@@ -9767,10 +9537,9 @@
           <a:p>
             <a:pPr algn="ctr"/>
             <a:r>
-              <a:rPr lang="es-ES" dirty="0"/>
+              <a:rPr lang="es-ES_tradnl" noProof="1"/>
               <a:t>91.67%</a:t>
             </a:r>
-            <a:endParaRPr lang="en-GB" dirty="0"/>
           </a:p>
         </p:txBody>
       </p:sp>
@@ -9970,29 +9739,16 @@
               <a:buNone/>
             </a:pPr>
             <a:r>
-              <a:rPr lang="en-US" b="1" dirty="0"/>
-              <a:t>Mes </a:t>
-            </a:r>
-            <a:r>
-              <a:rPr lang="en-US" b="1" dirty="0" err="1"/>
-              <a:t>pico</a:t>
-            </a:r>
-            <a:r>
-              <a:rPr lang="en-US" b="1" dirty="0"/>
-              <a:t> carga </a:t>
-            </a:r>
-            <a:r>
-              <a:rPr lang="en-US" b="1" dirty="0" err="1"/>
-              <a:t>ausencia</a:t>
-            </a:r>
-            <a:endParaRPr lang="en-US" b="1" dirty="0"/>
+              <a:rPr lang="es-ES_tradnl" b="1" noProof="1"/>
+              <a:t>Mes pico carga ausencia</a:t>
+            </a:r>
           </a:p>
           <a:p>
             <a:pPr algn="ctr"/>
-            <a:endParaRPr lang="en-US" b="1" dirty="0"/>
-          </a:p>
-          <a:p>
-            <a:endParaRPr lang="en-US" dirty="0"/>
+            <a:endParaRPr lang="es-ES_tradnl" b="1" noProof="1"/>
+          </a:p>
+          <a:p>
+            <a:endParaRPr lang="es-ES_tradnl" noProof="1"/>
           </a:p>
         </p:txBody>
       </p:sp>
@@ -10039,17 +9795,16 @@
           <a:p>
             <a:pPr algn="ctr"/>
             <a:r>
-              <a:rPr lang="es-ES" dirty="0"/>
+              <a:rPr lang="es-ES_tradnl" noProof="1"/>
               <a:t>Marzo </a:t>
             </a:r>
           </a:p>
           <a:p>
             <a:pPr algn="ctr"/>
             <a:r>
-              <a:rPr lang="es-ES" dirty="0"/>
+              <a:rPr lang="es-ES_tradnl" noProof="1"/>
               <a:t>755 horas</a:t>
             </a:r>
-            <a:endParaRPr lang="en-GB" dirty="0"/>
           </a:p>
         </p:txBody>
       </p:sp>
@@ -10249,12 +10004,8 @@
               <a:buNone/>
             </a:pPr>
             <a:r>
-              <a:rPr lang="en-US" b="1" dirty="0" err="1"/>
-              <a:t>Motivo</a:t>
-            </a:r>
-            <a:r>
-              <a:rPr lang="en-US" b="1" dirty="0"/>
-              <a:t> Modal</a:t>
+              <a:rPr lang="es-ES_tradnl" b="1" noProof="1"/>
+              <a:t>Motivo Modal</a:t>
             </a:r>
           </a:p>
         </p:txBody>
@@ -10455,34 +10206,9 @@
               <a:buNone/>
             </a:pPr>
             <a:r>
-              <a:rPr lang="en-US" b="1" dirty="0" err="1"/>
-              <a:t>Indice</a:t>
-            </a:r>
-            <a:r>
-              <a:rPr lang="en-US" b="1" dirty="0"/>
-              <a:t> </a:t>
-            </a:r>
-            <a:r>
-              <a:rPr lang="en-US" b="1" dirty="0" err="1"/>
-              <a:t>Eficiencia</a:t>
-            </a:r>
-            <a:r>
-              <a:rPr lang="en-US" b="1" dirty="0"/>
-              <a:t> </a:t>
-            </a:r>
-            <a:r>
-              <a:rPr lang="en-US" b="1" dirty="0" err="1"/>
-              <a:t>relativa</a:t>
-            </a:r>
-            <a:r>
-              <a:rPr lang="en-US" b="1" dirty="0"/>
-              <a:t> carga </a:t>
-            </a:r>
-            <a:r>
-              <a:rPr lang="en-US" b="1" dirty="0" err="1"/>
-              <a:t>laboral</a:t>
-            </a:r>
-            <a:endParaRPr lang="en-US" b="1" dirty="0"/>
+              <a:rPr lang="es-ES_tradnl" b="1" noProof="1"/>
+              <a:t>Indice Eficiencia relativa carga laboral</a:t>
+            </a:r>
           </a:p>
         </p:txBody>
       </p:sp>
@@ -10529,25 +10255,16 @@
           <a:p>
             <a:pPr algn="ctr"/>
             <a:r>
-              <a:rPr lang="es-ES" dirty="0"/>
-              <a:t>Medical </a:t>
-            </a:r>
-            <a:r>
-              <a:rPr lang="es-ES" dirty="0" err="1"/>
-              <a:t>Consultation</a:t>
-            </a:r>
-            <a:r>
-              <a:rPr lang="es-ES" dirty="0"/>
-              <a:t> </a:t>
+              <a:rPr lang="es-ES_tradnl" noProof="1"/>
+              <a:t>Medical Consultation </a:t>
             </a:r>
           </a:p>
           <a:p>
             <a:pPr algn="ctr"/>
             <a:r>
-              <a:rPr lang="es-ES" dirty="0"/>
+              <a:rPr lang="es-ES_tradnl" noProof="1"/>
               <a:t>142 eventos</a:t>
             </a:r>
-            <a:endParaRPr lang="en-GB" dirty="0"/>
           </a:p>
         </p:txBody>
       </p:sp>
@@ -10594,10 +10311,9 @@
           <a:p>
             <a:pPr algn="ctr"/>
             <a:r>
-              <a:rPr lang="es-ES" dirty="0"/>
+              <a:rPr lang="es-ES_tradnl" noProof="1"/>
               <a:t>0.35</a:t>
             </a:r>
-            <a:endParaRPr lang="en-GB" dirty="0"/>
           </a:p>
         </p:txBody>
       </p:sp>
@@ -10658,7 +10374,7 @@
           <a:lstStyle/>
           <a:p>
             <a:r>
-              <a:rPr lang="en-US" dirty="0"/>
+              <a:rPr lang="es-ES_tradnl" noProof="1"/>
               <a:t>Agenda </a:t>
             </a:r>
           </a:p>
@@ -10692,112 +10408,35 @@
           </a:bodyPr>
           <a:lstStyle/>
           <a:p>
-            <a:endParaRPr lang="en-US" dirty="0"/>
-          </a:p>
-          <a:p>
-            <a:r>
-              <a:rPr lang="en-US" dirty="0" err="1"/>
-              <a:t>Perfil</a:t>
-            </a:r>
-            <a:r>
-              <a:rPr lang="en-US" dirty="0"/>
-              <a:t> </a:t>
-            </a:r>
-            <a:r>
-              <a:rPr lang="en-US" dirty="0" err="1"/>
-              <a:t>sociodemográfico</a:t>
-            </a:r>
-            <a:endParaRPr lang="en-US" dirty="0"/>
-          </a:p>
-          <a:p>
-            <a:r>
-              <a:rPr lang="en-US" dirty="0" err="1"/>
-              <a:t>Estrategias</a:t>
-            </a:r>
-            <a:r>
-              <a:rPr lang="en-US" dirty="0"/>
-              <a:t> de </a:t>
-            </a:r>
-            <a:r>
-              <a:rPr lang="en-US" dirty="0" err="1"/>
-              <a:t>Compromiso</a:t>
-            </a:r>
-            <a:r>
-              <a:rPr lang="en-US" dirty="0"/>
-              <a:t> y Desarrollo</a:t>
-            </a:r>
-          </a:p>
-          <a:p>
-            <a:r>
-              <a:rPr lang="en-US" dirty="0" err="1"/>
-              <a:t>Analisis</a:t>
-            </a:r>
-            <a:r>
-              <a:rPr lang="en-US" dirty="0"/>
-              <a:t> de </a:t>
-            </a:r>
-            <a:r>
-              <a:rPr lang="en-US" dirty="0" err="1"/>
-              <a:t>Ausentismo</a:t>
-            </a:r>
-            <a:r>
-              <a:rPr lang="en-US" dirty="0"/>
-              <a:t>: </a:t>
-            </a:r>
-            <a:r>
-              <a:rPr lang="en-US" dirty="0" err="1"/>
-              <a:t>Magnitud</a:t>
-            </a:r>
-            <a:r>
-              <a:rPr lang="en-US" dirty="0"/>
-              <a:t> y </a:t>
-            </a:r>
-            <a:r>
-              <a:rPr lang="en-US" dirty="0" err="1"/>
-              <a:t>variación</a:t>
-            </a:r>
-            <a:r>
-              <a:rPr lang="en-US" dirty="0"/>
-              <a:t> temporal</a:t>
-            </a:r>
-          </a:p>
-          <a:p>
-            <a:r>
-              <a:rPr lang="en-US" dirty="0" err="1"/>
-              <a:t>Estrategias</a:t>
-            </a:r>
-            <a:r>
-              <a:rPr lang="en-US" dirty="0"/>
-              <a:t> para </a:t>
-            </a:r>
-            <a:r>
-              <a:rPr lang="en-US" dirty="0" err="1"/>
-              <a:t>reducir</a:t>
-            </a:r>
-            <a:r>
-              <a:rPr lang="en-US" dirty="0"/>
-              <a:t> </a:t>
-            </a:r>
-            <a:r>
-              <a:rPr lang="en-US" dirty="0" err="1"/>
-              <a:t>el</a:t>
-            </a:r>
-            <a:r>
-              <a:rPr lang="en-US" dirty="0"/>
-              <a:t> </a:t>
-            </a:r>
-            <a:r>
-              <a:rPr lang="en-US" dirty="0" err="1"/>
-              <a:t>Ausentismo</a:t>
-            </a:r>
-            <a:r>
-              <a:rPr lang="en-US" dirty="0"/>
-              <a:t> </a:t>
-            </a:r>
-          </a:p>
-          <a:p>
-            <a:r>
-              <a:rPr lang="en-US" dirty="0"/>
+            <a:endParaRPr lang="es-ES_tradnl" noProof="1"/>
+          </a:p>
+          <a:p>
+            <a:r>
+              <a:rPr lang="es-ES_tradnl" noProof="1"/>
+              <a:t>Perfil sociodemográfico</a:t>
+            </a:r>
+          </a:p>
+          <a:p>
+            <a:r>
+              <a:rPr lang="es-ES_tradnl" noProof="1"/>
+              <a:t>Estrategias de Compromiso y Desarrollo</a:t>
+            </a:r>
+          </a:p>
+          <a:p>
+            <a:r>
+              <a:rPr lang="es-ES_tradnl" noProof="1"/>
+              <a:t>Análisis de Ausentismo: Magnitud y variación temporal</a:t>
+            </a:r>
+          </a:p>
+          <a:p>
+            <a:r>
+              <a:rPr lang="es-ES_tradnl" noProof="1"/>
+              <a:t>Estrategias para reducir el Ausentismo </a:t>
+            </a:r>
+          </a:p>
+          <a:p>
+            <a:r>
+              <a:rPr lang="es-ES_tradnl" noProof="1"/>
               <a:t>KPIs</a:t>
             </a:r>
           </a:p>
@@ -10825,11 +10464,11 @@
           <a:lstStyle/>
           <a:p>
             <a:fld id="{47FEACEE-25B4-4A2D-B147-27296E36371D}" type="slidenum">
-              <a:rPr lang="en-US" altLang="zh-CN" noProof="0" smtClean="0"/>
+              <a:rPr lang="es-ES_tradnl" noProof="1" smtClean="0"/>
               <a:pPr/>
               <a:t>2</a:t>
             </a:fld>
-            <a:endParaRPr lang="en-US" altLang="zh-CN" noProof="0" dirty="0"/>
+            <a:endParaRPr lang="es-ES_tradnl" noProof="1"/>
           </a:p>
         </p:txBody>
       </p:sp>
@@ -10898,37 +10537,21 @@
           <a:lstStyle/>
           <a:p>
             <a:r>
-              <a:rPr lang="en-US" dirty="0" err="1">
+              <a:rPr lang="es-ES_tradnl" noProof="1">
                 <a:solidFill>
                   <a:schemeClr val="bg1"/>
                 </a:solidFill>
               </a:rPr>
-              <a:t>Perfil</a:t>
-            </a:r>
-            <a:r>
-              <a:rPr lang="en-US" dirty="0">
-                <a:solidFill>
-                  <a:schemeClr val="bg1"/>
-                </a:solidFill>
-              </a:rPr>
-              <a:t> </a:t>
-            </a:r>
-            <a:r>
-              <a:rPr lang="en-US" dirty="0" err="1">
-                <a:solidFill>
-                  <a:schemeClr val="bg1"/>
-                </a:solidFill>
-              </a:rPr>
-              <a:t>sociodemográfico</a:t>
+              <a:t>Perfil sociodemográfico</a:t>
             </a:r>
             <a:br>
-              <a:rPr lang="en-US" dirty="0">
+              <a:rPr lang="es-ES_tradnl" noProof="1">
                 <a:solidFill>
                   <a:schemeClr val="bg1"/>
                 </a:solidFill>
               </a:rPr>
             </a:br>
-            <a:endParaRPr lang="en-US" dirty="0">
+            <a:endParaRPr lang="es-ES_tradnl" noProof="1">
               <a:solidFill>
                 <a:schemeClr val="bg1"/>
               </a:solidFill>
@@ -10962,7 +10585,7 @@
           <a:bodyPr/>
           <a:lstStyle/>
           <a:p>
-            <a:endParaRPr lang="en-US" dirty="0"/>
+            <a:endParaRPr lang="es-ES_tradnl" noProof="1"/>
           </a:p>
         </p:txBody>
       </p:sp>
@@ -11135,7 +10758,7 @@
               <a:defRPr/>
             </a:pPr>
             <a:fld id="{47FEACEE-25B4-4A2D-B147-27296E36371D}" type="slidenum">
-              <a:rPr kumimoji="0" lang="en-US" altLang="zh-CN" sz="1200" u="none" strike="noStrike" kern="1200" cap="none" spc="0" normalizeH="0" baseline="0" smtClean="0">
+              <a:rPr kumimoji="0" lang="es-ES_tradnl" sz="1200" u="none" strike="noStrike" kern="1200" cap="none" spc="0" normalizeH="0" baseline="0" noProof="1" smtClean="0">
                 <a:ln>
                   <a:noFill/>
                 </a:ln>
@@ -11165,7 +10788,7 @@
               </a:pPr>
               <a:t>4</a:t>
             </a:fld>
-            <a:endParaRPr kumimoji="0" lang="en-US" altLang="zh-CN" sz="1200" u="none" strike="noStrike" kern="1200" cap="none" spc="0" normalizeH="0" baseline="0" dirty="0">
+            <a:endParaRPr kumimoji="0" lang="es-ES_tradnl" sz="1200" u="none" strike="noStrike" kern="1200" cap="none" spc="0" normalizeH="0" baseline="0" noProof="1">
               <a:ln>
                 <a:noFill/>
               </a:ln>
@@ -11201,11 +10824,11 @@
           <a:lstStyle/>
           <a:p>
             <a:fld id="{47FEACEE-25B4-4A2D-B147-27296E36371D}" type="slidenum">
-              <a:rPr lang="en-US" altLang="zh-CN" noProof="0" smtClean="0"/>
+              <a:rPr lang="es-ES_tradnl" noProof="1" smtClean="0"/>
               <a:pPr/>
               <a:t>4</a:t>
             </a:fld>
-            <a:endParaRPr lang="en-US" altLang="zh-CN" noProof="0" dirty="0"/>
+            <a:endParaRPr lang="es-ES_tradnl" noProof="1"/>
           </a:p>
         </p:txBody>
       </p:sp>
@@ -11238,10 +10861,9 @@
           <a:lstStyle/>
           <a:p>
             <a:r>
-              <a:rPr lang="es-ES" sz="4000" dirty="0"/>
+              <a:rPr lang="es-ES_tradnl" sz="4000" noProof="1"/>
               <a:t>Perfil sociodemográfico</a:t>
             </a:r>
-            <a:endParaRPr lang="en-GB" sz="4000" dirty="0"/>
           </a:p>
         </p:txBody>
       </p:sp>
@@ -11295,7 +10917,7 @@
         <p:spPr>
           <a:xfrm>
             <a:off x="1031358" y="5018567"/>
-            <a:ext cx="3477875" cy="369332"/>
+            <a:ext cx="3755259" cy="369332"/>
           </a:xfrm>
           <a:prstGeom prst="rect">
             <a:avLst/>
@@ -11309,15 +10931,11 @@
           <a:lstStyle/>
           <a:p>
             <a:r>
-              <a:rPr lang="es-ES" b="1" dirty="0" err="1"/>
-              <a:t>Educacion</a:t>
-            </a:r>
-            <a:r>
-              <a:rPr lang="es-ES" b="1" dirty="0"/>
-              <a:t>: </a:t>
-            </a:r>
-            <a:r>
-              <a:rPr lang="es-ES" dirty="0"/>
+              <a:rPr lang="es-ES_tradnl" b="1" noProof="1"/>
+              <a:t>Educación: </a:t>
+            </a:r>
+            <a:r>
+              <a:rPr lang="es-ES_tradnl" noProof="1"/>
               <a:t>77.8% No universitarios</a:t>
             </a:r>
           </a:p>
@@ -11352,24 +10970,24 @@
           <a:lstStyle/>
           <a:p>
             <a:r>
-              <a:rPr lang="es-ES" b="1" dirty="0"/>
+              <a:rPr lang="es-ES_tradnl" b="1" noProof="1"/>
               <a:t>Edad media: </a:t>
             </a:r>
             <a:r>
-              <a:rPr lang="es-ES" dirty="0"/>
+              <a:rPr lang="es-ES_tradnl" noProof="1"/>
               <a:t>38 años</a:t>
             </a:r>
           </a:p>
           <a:p>
-            <a:endParaRPr lang="es-ES" b="1" dirty="0"/>
-          </a:p>
-          <a:p>
-            <a:r>
-              <a:rPr lang="es-ES" b="1" dirty="0"/>
+            <a:endParaRPr lang="es-ES_tradnl" b="1" noProof="1"/>
+          </a:p>
+          <a:p>
+            <a:r>
+              <a:rPr lang="es-ES_tradnl" b="1" noProof="1"/>
               <a:t>Intervalo: </a:t>
             </a:r>
             <a:r>
-              <a:rPr lang="es-ES" dirty="0"/>
+              <a:rPr lang="es-ES_tradnl" noProof="1"/>
               <a:t>27-58 años</a:t>
             </a:r>
           </a:p>
@@ -11404,14 +11022,10 @@
           <a:lstStyle/>
           <a:p>
             <a:r>
-              <a:rPr lang="es-ES" b="1" dirty="0" err="1"/>
-              <a:t>Num</a:t>
-            </a:r>
-            <a:r>
-              <a:rPr lang="es-ES" b="1" dirty="0"/>
-              <a:t>. Hijos: entre 0-4</a:t>
-            </a:r>
-            <a:endParaRPr lang="es-ES" dirty="0"/>
+              <a:rPr lang="es-ES_tradnl" b="1" noProof="1"/>
+              <a:t>Num. Hijos: entre 0-4</a:t>
+            </a:r>
+            <a:endParaRPr lang="es-ES_tradnl" noProof="1"/>
           </a:p>
         </p:txBody>
       </p:sp>
@@ -11486,41 +11100,17 @@
           <a:lstStyle/>
           <a:p>
             <a:r>
-              <a:rPr lang="en-US" dirty="0" err="1">
+              <a:rPr lang="es-ES_tradnl" noProof="1">
                 <a:solidFill>
                   <a:schemeClr val="bg1"/>
                 </a:solidFill>
               </a:rPr>
-              <a:t>Estrategias</a:t>
-            </a:r>
-            <a:r>
-              <a:rPr lang="en-US" dirty="0">
-                <a:solidFill>
-                  <a:schemeClr val="bg1"/>
-                </a:solidFill>
-              </a:rPr>
-              <a:t> de </a:t>
-            </a:r>
-            <a:r>
-              <a:rPr lang="en-US" dirty="0" err="1">
-                <a:solidFill>
-                  <a:schemeClr val="bg1"/>
-                </a:solidFill>
-              </a:rPr>
-              <a:t>Compromiso</a:t>
-            </a:r>
-            <a:r>
-              <a:rPr lang="en-US" dirty="0">
-                <a:solidFill>
-                  <a:schemeClr val="bg1"/>
-                </a:solidFill>
-              </a:rPr>
-              <a:t> y Desarrollo</a:t>
+              <a:t>Estrategias de Compromiso y Desarrollo</a:t>
             </a:r>
             <a:br>
-              <a:rPr lang="en-US" dirty="0"/>
+              <a:rPr lang="es-ES_tradnl" noProof="1"/>
             </a:br>
-            <a:endParaRPr lang="en-US" dirty="0">
+            <a:endParaRPr lang="es-ES_tradnl" noProof="1">
               <a:solidFill>
                 <a:schemeClr val="bg1"/>
               </a:solidFill>
@@ -11554,7 +11144,7 @@
           <a:bodyPr/>
           <a:lstStyle/>
           <a:p>
-            <a:endParaRPr lang="en-US" dirty="0"/>
+            <a:endParaRPr lang="es-ES_tradnl" noProof="1"/>
           </a:p>
         </p:txBody>
       </p:sp>
@@ -11621,20 +11211,8 @@
           <a:lstStyle/>
           <a:p>
             <a:r>
-              <a:rPr lang="en-US" dirty="0" err="1"/>
-              <a:t>Estrategias</a:t>
-            </a:r>
-            <a:r>
-              <a:rPr lang="en-US" dirty="0"/>
-              <a:t> de </a:t>
-            </a:r>
-            <a:r>
-              <a:rPr lang="en-US" dirty="0" err="1"/>
-              <a:t>Compromiso</a:t>
-            </a:r>
-            <a:r>
-              <a:rPr lang="en-US" dirty="0"/>
-              <a:t> y Desarrollo</a:t>
+              <a:rPr lang="es-ES_tradnl" noProof="1"/>
+              <a:t>Estrategias de Compromiso y Desarrollo</a:t>
             </a:r>
           </a:p>
         </p:txBody>
@@ -11778,7 +11356,7 @@
               <a:defRPr/>
             </a:pPr>
             <a:fld id="{47FEACEE-25B4-4A2D-B147-27296E36371D}" type="slidenum">
-              <a:rPr kumimoji="0" lang="en-US" altLang="zh-CN" sz="1200" u="none" strike="noStrike" kern="1200" cap="none" spc="0" normalizeH="0" baseline="0" smtClean="0">
+              <a:rPr kumimoji="0" lang="es-ES_tradnl" sz="1200" u="none" strike="noStrike" kern="1200" cap="none" spc="0" normalizeH="0" baseline="0" noProof="1" smtClean="0">
                 <a:ln>
                   <a:noFill/>
                 </a:ln>
@@ -11808,7 +11386,7 @@
               </a:pPr>
               <a:t>6</a:t>
             </a:fld>
-            <a:endParaRPr kumimoji="0" lang="en-US" altLang="zh-CN" sz="1200" u="none" strike="noStrike" kern="1200" cap="none" spc="0" normalizeH="0" baseline="0" dirty="0">
+            <a:endParaRPr kumimoji="0" lang="es-ES_tradnl" sz="1200" u="none" strike="noStrike" kern="1200" cap="none" spc="0" normalizeH="0" baseline="0" noProof="1">
               <a:ln>
                 <a:noFill/>
               </a:ln>
@@ -11844,11 +11422,11 @@
           <a:lstStyle/>
           <a:p>
             <a:fld id="{47FEACEE-25B4-4A2D-B147-27296E36371D}" type="slidenum">
-              <a:rPr lang="en-US" altLang="zh-CN" noProof="0" smtClean="0"/>
+              <a:rPr lang="es-ES_tradnl" noProof="1" smtClean="0"/>
               <a:pPr/>
               <a:t>6</a:t>
             </a:fld>
-            <a:endParaRPr lang="en-US" altLang="zh-CN" noProof="0" dirty="0"/>
+            <a:endParaRPr lang="es-ES_tradnl" noProof="1"/>
           </a:p>
         </p:txBody>
       </p:sp>
@@ -11874,122 +11452,52 @@
           <a:lstStyle/>
           <a:p>
             <a:r>
-              <a:rPr lang="es-ES" b="1" dirty="0">
+              <a:rPr lang="es-ES_tradnl" b="1" noProof="1">
                 <a:effectLst/>
                 <a:latin typeface="Consolas" panose="020B0609020204030204" pitchFamily="49" charset="0"/>
               </a:rPr>
-              <a:t>Planes de </a:t>
-            </a:r>
-            <a:r>
-              <a:rPr lang="es-ES" b="1" dirty="0" err="1">
-                <a:effectLst/>
+              <a:t>Planes de micro-formación y Upskilling</a:t>
+            </a:r>
+          </a:p>
+          <a:p>
+            <a:pPr lvl="1"/>
+            <a:r>
+              <a:rPr lang="es-ES_tradnl" b="1" noProof="1">
                 <a:latin typeface="Consolas" panose="020B0609020204030204" pitchFamily="49" charset="0"/>
               </a:rPr>
-              <a:t>micro-formación</a:t>
-            </a:r>
-            <a:r>
-              <a:rPr lang="es-ES" b="1" dirty="0">
-                <a:effectLst/>
-                <a:latin typeface="Consolas" panose="020B0609020204030204" pitchFamily="49" charset="0"/>
-              </a:rPr>
-              <a:t> y </a:t>
-            </a:r>
-            <a:r>
-              <a:rPr lang="es-ES" b="1" dirty="0" err="1">
-                <a:effectLst/>
-                <a:latin typeface="Consolas" panose="020B0609020204030204" pitchFamily="49" charset="0"/>
-              </a:rPr>
-              <a:t>Upskilling</a:t>
-            </a:r>
-            <a:endParaRPr lang="es-ES" b="1" dirty="0">
+              <a:t>Certificaciones técnicas y otros Desarrollos Profesionales</a:t>
+            </a:r>
+            <a:endParaRPr lang="es-ES_tradnl" b="1" noProof="1">
               <a:effectLst/>
               <a:latin typeface="Consolas" panose="020B0609020204030204" pitchFamily="49" charset="0"/>
             </a:endParaRPr>
           </a:p>
           <a:p>
-            <a:pPr lvl="1"/>
-            <a:r>
-              <a:rPr lang="es-ES" b="1" dirty="0">
-                <a:latin typeface="Consolas" panose="020B0609020204030204" pitchFamily="49" charset="0"/>
-              </a:rPr>
-              <a:t>Certificaciones técnicas y otros Desarrollos Professional</a:t>
-            </a:r>
-            <a:endParaRPr lang="es-ES" b="1" dirty="0">
+            <a:endParaRPr lang="es-ES_tradnl" b="1" noProof="1">
+              <a:latin typeface="Consolas" panose="020B0609020204030204" pitchFamily="49" charset="0"/>
+            </a:endParaRPr>
+          </a:p>
+          <a:p>
+            <a:endParaRPr lang="es-ES_tradnl" b="0" noProof="1">
               <a:effectLst/>
               <a:latin typeface="Consolas" panose="020B0609020204030204" pitchFamily="49" charset="0"/>
             </a:endParaRPr>
           </a:p>
           <a:p>
-            <a:endParaRPr lang="es-ES" b="1" dirty="0">
-              <a:latin typeface="Consolas" panose="020B0609020204030204" pitchFamily="49" charset="0"/>
-            </a:endParaRPr>
-          </a:p>
-          <a:p>
-            <a:endParaRPr lang="es-ES" b="0" dirty="0">
-              <a:effectLst/>
-              <a:latin typeface="Consolas" panose="020B0609020204030204" pitchFamily="49" charset="0"/>
-            </a:endParaRPr>
-          </a:p>
-          <a:p>
-            <a:r>
-              <a:rPr lang="en-GB" b="1" dirty="0" err="1">
+            <a:r>
+              <a:rPr lang="es-ES_tradnl" b="1" noProof="1">
                 <a:latin typeface="Consolas" panose="020B0609020204030204" pitchFamily="49" charset="0"/>
               </a:rPr>
-              <a:t>Politicas</a:t>
-            </a:r>
-            <a:r>
-              <a:rPr lang="en-GB" b="1" dirty="0">
+              <a:t>Políticas de conciliación</a:t>
+            </a:r>
+          </a:p>
+          <a:p>
+            <a:pPr lvl="1"/>
+            <a:r>
+              <a:rPr lang="es-ES_tradnl" b="1" noProof="1">
                 <a:latin typeface="Consolas" panose="020B0609020204030204" pitchFamily="49" charset="0"/>
               </a:rPr>
-              <a:t> de </a:t>
-            </a:r>
-            <a:r>
-              <a:rPr lang="en-GB" b="1" dirty="0" err="1">
-                <a:latin typeface="Consolas" panose="020B0609020204030204" pitchFamily="49" charset="0"/>
-              </a:rPr>
-              <a:t>conciliación</a:t>
-            </a:r>
-            <a:endParaRPr lang="en-GB" b="1" dirty="0">
-              <a:latin typeface="Consolas" panose="020B0609020204030204" pitchFamily="49" charset="0"/>
-            </a:endParaRPr>
-          </a:p>
-          <a:p>
-            <a:pPr lvl="1"/>
-            <a:r>
-              <a:rPr lang="en-GB" b="1" dirty="0" err="1">
-                <a:latin typeface="Consolas" panose="020B0609020204030204" pitchFamily="49" charset="0"/>
-              </a:rPr>
-              <a:t>Flexibilidad</a:t>
-            </a:r>
-            <a:r>
-              <a:rPr lang="en-GB" b="1" dirty="0">
-                <a:latin typeface="Consolas" panose="020B0609020204030204" pitchFamily="49" charset="0"/>
-              </a:rPr>
-              <a:t> </a:t>
-            </a:r>
-            <a:r>
-              <a:rPr lang="en-GB" b="1" dirty="0" err="1">
-                <a:latin typeface="Consolas" panose="020B0609020204030204" pitchFamily="49" charset="0"/>
-              </a:rPr>
-              <a:t>horaria</a:t>
-            </a:r>
-            <a:r>
-              <a:rPr lang="en-GB" b="1" dirty="0">
-                <a:latin typeface="Consolas" panose="020B0609020204030204" pitchFamily="49" charset="0"/>
-              </a:rPr>
-              <a:t> (</a:t>
-            </a:r>
-            <a:r>
-              <a:rPr lang="en-GB" b="1" dirty="0" err="1">
-                <a:latin typeface="Consolas" panose="020B0609020204030204" pitchFamily="49" charset="0"/>
-              </a:rPr>
-              <a:t>bolsas</a:t>
-            </a:r>
-            <a:r>
-              <a:rPr lang="en-GB" b="1" dirty="0">
-                <a:latin typeface="Consolas" panose="020B0609020204030204" pitchFamily="49" charset="0"/>
-              </a:rPr>
-              <a:t> de horas)</a:t>
+              <a:t>Flexibilidad horaria (bolsas de horas)</a:t>
             </a:r>
           </a:p>
         </p:txBody>
@@ -12065,34 +11573,13 @@
           <a:lstStyle/>
           <a:p>
             <a:r>
-              <a:rPr lang="en-US" dirty="0" err="1">
+              <a:rPr lang="es-ES_tradnl" noProof="1">
                 <a:solidFill>
                   <a:schemeClr val="bg1"/>
                 </a:solidFill>
               </a:rPr>
-              <a:t>Analisis</a:t>
-            </a:r>
-            <a:r>
-              <a:rPr lang="en-US" dirty="0">
-                <a:solidFill>
-                  <a:schemeClr val="bg1"/>
-                </a:solidFill>
-              </a:rPr>
-              <a:t> </a:t>
-            </a:r>
-            <a:r>
-              <a:rPr lang="en-US" dirty="0" err="1">
-                <a:solidFill>
-                  <a:schemeClr val="bg1"/>
-                </a:solidFill>
-              </a:rPr>
-              <a:t>Ausentismo</a:t>
-            </a:r>
-            <a:endParaRPr lang="en-US" dirty="0">
-              <a:solidFill>
-                <a:schemeClr val="bg1"/>
-              </a:solidFill>
-            </a:endParaRPr>
+              <a:t>Analisis Ausentismo</a:t>
+            </a:r>
           </a:p>
         </p:txBody>
       </p:sp>
@@ -12123,20 +11610,8 @@
           <a:lstStyle/>
           <a:p>
             <a:r>
-              <a:rPr lang="en-US" dirty="0" err="1"/>
-              <a:t>Magnitud</a:t>
-            </a:r>
-            <a:r>
-              <a:rPr lang="en-US" dirty="0"/>
-              <a:t> y </a:t>
-            </a:r>
-            <a:r>
-              <a:rPr lang="en-US" dirty="0" err="1"/>
-              <a:t>análisis</a:t>
-            </a:r>
-            <a:r>
-              <a:rPr lang="en-US" dirty="0"/>
-              <a:t> temporal</a:t>
+              <a:rPr lang="es-ES_tradnl" noProof="1"/>
+              <a:t>Magnitud y análisis temporal</a:t>
             </a:r>
           </a:p>
         </p:txBody>
@@ -12204,12 +11679,8 @@
           <a:lstStyle/>
           <a:p>
             <a:r>
-              <a:rPr lang="es-ES" dirty="0" err="1"/>
-              <a:t>Analisis</a:t>
-            </a:r>
-            <a:r>
-              <a:rPr lang="es-ES" dirty="0"/>
-              <a:t> de la Magnitud del Ausentismo</a:t>
+              <a:rPr lang="es-ES_tradnl" noProof="1"/>
+              <a:t>Analisis de la Magnitud del Ausentismo</a:t>
             </a:r>
           </a:p>
         </p:txBody>
@@ -12353,7 +11824,7 @@
               <a:defRPr/>
             </a:pPr>
             <a:fld id="{47FEACEE-25B4-4A2D-B147-27296E36371D}" type="slidenum">
-              <a:rPr kumimoji="0" lang="en-US" altLang="zh-CN" sz="1200" u="none" strike="noStrike" kern="1200" cap="none" spc="0" normalizeH="0" baseline="0" smtClean="0">
+              <a:rPr kumimoji="0" lang="es-ES_tradnl" sz="1200" u="none" strike="noStrike" kern="1200" cap="none" spc="0" normalizeH="0" baseline="0" noProof="1" smtClean="0">
                 <a:ln>
                   <a:noFill/>
                 </a:ln>
@@ -12383,7 +11854,7 @@
               </a:pPr>
               <a:t>8</a:t>
             </a:fld>
-            <a:endParaRPr kumimoji="0" lang="en-US" altLang="zh-CN" sz="1200" u="none" strike="noStrike" kern="1200" cap="none" spc="0" normalizeH="0" baseline="0" dirty="0">
+            <a:endParaRPr kumimoji="0" lang="es-ES_tradnl" sz="1200" u="none" strike="noStrike" kern="1200" cap="none" spc="0" normalizeH="0" baseline="0" noProof="1">
               <a:ln>
                 <a:noFill/>
               </a:ln>
@@ -12419,11 +11890,11 @@
           <a:lstStyle/>
           <a:p>
             <a:fld id="{47FEACEE-25B4-4A2D-B147-27296E36371D}" type="slidenum">
-              <a:rPr lang="en-US" altLang="zh-CN" noProof="0" smtClean="0"/>
+              <a:rPr lang="es-ES_tradnl" noProof="1" smtClean="0"/>
               <a:pPr/>
               <a:t>8</a:t>
             </a:fld>
-            <a:endParaRPr lang="en-US" altLang="zh-CN" noProof="0" dirty="0"/>
+            <a:endParaRPr lang="es-ES_tradnl" noProof="1"/>
           </a:p>
         </p:txBody>
       </p:sp>
@@ -12554,12 +12025,8 @@
           <a:lstStyle/>
           <a:p>
             <a:r>
-              <a:rPr lang="es-ES" dirty="0" err="1"/>
-              <a:t>Analisis</a:t>
-            </a:r>
-            <a:r>
-              <a:rPr lang="es-ES" dirty="0"/>
-              <a:t> de la Variación Temporal del Ausentismo</a:t>
+              <a:rPr lang="es-ES_tradnl" noProof="1"/>
+              <a:t>Analisis de la Variación Temporal del Ausentismo</a:t>
             </a:r>
           </a:p>
         </p:txBody>
@@ -12703,7 +12170,7 @@
               <a:defRPr/>
             </a:pPr>
             <a:fld id="{47FEACEE-25B4-4A2D-B147-27296E36371D}" type="slidenum">
-              <a:rPr kumimoji="0" lang="en-US" altLang="zh-CN" sz="1200" u="none" strike="noStrike" kern="1200" cap="none" spc="0" normalizeH="0" baseline="0" smtClean="0">
+              <a:rPr kumimoji="0" lang="es-ES_tradnl" sz="1200" u="none" strike="noStrike" kern="1200" cap="none" spc="0" normalizeH="0" baseline="0" noProof="1" smtClean="0">
                 <a:ln>
                   <a:noFill/>
                 </a:ln>
@@ -12733,7 +12200,7 @@
               </a:pPr>
               <a:t>9</a:t>
             </a:fld>
-            <a:endParaRPr kumimoji="0" lang="en-US" altLang="zh-CN" sz="1200" u="none" strike="noStrike" kern="1200" cap="none" spc="0" normalizeH="0" baseline="0" dirty="0">
+            <a:endParaRPr kumimoji="0" lang="es-ES_tradnl" sz="1200" u="none" strike="noStrike" kern="1200" cap="none" spc="0" normalizeH="0" baseline="0" noProof="1">
               <a:ln>
                 <a:noFill/>
               </a:ln>
@@ -12769,11 +12236,11 @@
           <a:lstStyle/>
           <a:p>
             <a:fld id="{47FEACEE-25B4-4A2D-B147-27296E36371D}" type="slidenum">
-              <a:rPr lang="en-US" altLang="zh-CN" noProof="0" smtClean="0"/>
+              <a:rPr lang="es-ES_tradnl" noProof="1" smtClean="0"/>
               <a:pPr/>
               <a:t>9</a:t>
             </a:fld>
-            <a:endParaRPr lang="en-US" altLang="zh-CN" noProof="0" dirty="0"/>
+            <a:endParaRPr lang="es-ES_tradnl" noProof="1"/>
           </a:p>
         </p:txBody>
       </p:sp>

</xml_diff>